<commit_message>
Build G6 T4 Ecology (6 PPTs + 7 worksheets) and G7 T4 Chemistry Separation (6 PPTs + 7 worksheets) — Xuanwu Lake ecosystems, paddlefish extinction, panda adaptations, Korean DMZ biodiversity, Yangtze fishing ban, Chinese salt production, Korean soju/cheonilyeom, German Reinheitsgebot/Schnaps, Nanjing water treatment, forensic chromatography
</commit_message>
<xml_diff>
--- a/static/ppts/G6_Sci_T4_Adaptations.pptx
+++ b/static/ppts/G6_Sci_T4_Adaptations.pptx
@@ -10,9 +10,12 @@
     <p:sldId id="258" r:id="rId4"/>
     <p:sldId id="259" r:id="rId5"/>
     <p:sldId id="260" r:id="rId6"/>
+    <p:sldId id="261" r:id="rId7"/>
+    <p:sldId id="262" r:id="rId8"/>
+    <p:sldId id="263" r:id="rId9"/>
   </p:sldIdLst>
   <p:notesMasterIdLst>
-    <p:notesMasterId r:id="rId7"/>
+    <p:notesMasterId r:id="rId10"/>
   </p:notesMasterIdLst>
   <p:sldSz cx="9144000" cy="5143500"/>
   <p:notesSz cx="5143500" cy="9144000"/>
@@ -900,6 +903,270 @@
 </p:notes>
 </file>
 
+<file path=ppt/notesSlides/notesSlide6.xml><?xml version="1.0" encoding="utf-8"?>
+<p:notes xmlns:a="http://schemas.openxmlformats.org/drawingml/2006/main" xmlns:r="http://schemas.openxmlformats.org/officeDocument/2006/relationships" xmlns:p="http://schemas.openxmlformats.org/presentationml/2006/main">
+  <p:cSld>
+    <p:spTree>
+      <p:nvGrpSpPr>
+        <p:cNvPr id="1" name=""/>
+        <p:cNvGrpSpPr/>
+        <p:nvPr/>
+      </p:nvGrpSpPr>
+      <p:grpSpPr>
+        <a:xfrm>
+          <a:off x="0" y="0"/>
+          <a:ext cx="0" cy="0"/>
+          <a:chOff x="0" y="0"/>
+          <a:chExt cx="0" cy="0"/>
+        </a:xfrm>
+      </p:grpSpPr>
+      <p:sp>
+        <p:nvSpPr>
+          <p:cNvPr id="2" name="Slide Image Placeholder 1"/>
+          <p:cNvSpPr>
+            <a:spLocks noGrp="1" noRot="1" noChangeAspect="1"/>
+          </p:cNvSpPr>
+          <p:nvPr>
+            <p:ph type="sldImg"/>
+          </p:nvPr>
+        </p:nvSpPr>
+        <p:spPr/>
+      </p:sp>
+      <p:sp>
+        <p:nvSpPr>
+          <p:cNvPr id="3" name="Notes Placeholder 2"/>
+          <p:cNvSpPr>
+            <a:spLocks noGrp="1"/>
+          </p:cNvSpPr>
+          <p:nvPr>
+            <p:ph type="body" idx="1"/>
+          </p:nvPr>
+        </p:nvSpPr>
+        <p:spPr/>
+        <p:txBody>
+          <a:bodyPr/>
+          <a:lstStyle/>
+          <a:p>
+            <a:r>
+              <a:rPr lang="en-US" dirty="0"/>
+              <a:t/>
+            </a:r>
+            <a:endParaRPr lang="en-US" dirty="0"/>
+          </a:p>
+        </p:txBody>
+      </p:sp>
+      <p:sp>
+        <p:nvSpPr>
+          <p:cNvPr id="4" name="Slide Number Placeholder 3"/>
+          <p:cNvSpPr>
+            <a:spLocks noGrp="1"/>
+          </p:cNvSpPr>
+          <p:nvPr>
+            <p:ph type="sldNum" sz="quarter" idx="10"/>
+          </p:nvPr>
+        </p:nvSpPr>
+        <p:spPr/>
+        <p:txBody>
+          <a:bodyPr/>
+          <a:lstStyle/>
+          <a:p>
+            <a:fld id="{F7021451-1387-4CA6-816F-3879F97B5CBC}" type="slidenum">
+              <a:rPr lang="en-US"/>
+              <a:t>6</a:t>
+            </a:fld>
+            <a:endParaRPr lang="en-US"/>
+          </a:p>
+        </p:txBody>
+      </p:sp>
+    </p:spTree>
+    <p:extLst>
+      <p:ext uri="{BB962C8B-B14F-4D97-AF65-F5344CB8AC3E}">
+        <p14:creationId xmlns:p14="http://schemas.microsoft.com/office/powerpoint/2010/main" val="1024086991"/>
+      </p:ext>
+    </p:extLst>
+  </p:cSld>
+  <p:clrMapOvr>
+    <a:masterClrMapping/>
+  </p:clrMapOvr>
+</p:notes>
+</file>
+
+<file path=ppt/notesSlides/notesSlide7.xml><?xml version="1.0" encoding="utf-8"?>
+<p:notes xmlns:a="http://schemas.openxmlformats.org/drawingml/2006/main" xmlns:r="http://schemas.openxmlformats.org/officeDocument/2006/relationships" xmlns:p="http://schemas.openxmlformats.org/presentationml/2006/main">
+  <p:cSld>
+    <p:spTree>
+      <p:nvGrpSpPr>
+        <p:cNvPr id="1" name=""/>
+        <p:cNvGrpSpPr/>
+        <p:nvPr/>
+      </p:nvGrpSpPr>
+      <p:grpSpPr>
+        <a:xfrm>
+          <a:off x="0" y="0"/>
+          <a:ext cx="0" cy="0"/>
+          <a:chOff x="0" y="0"/>
+          <a:chExt cx="0" cy="0"/>
+        </a:xfrm>
+      </p:grpSpPr>
+      <p:sp>
+        <p:nvSpPr>
+          <p:cNvPr id="2" name="Slide Image Placeholder 1"/>
+          <p:cNvSpPr>
+            <a:spLocks noGrp="1" noRot="1" noChangeAspect="1"/>
+          </p:cNvSpPr>
+          <p:nvPr>
+            <p:ph type="sldImg"/>
+          </p:nvPr>
+        </p:nvSpPr>
+        <p:spPr/>
+      </p:sp>
+      <p:sp>
+        <p:nvSpPr>
+          <p:cNvPr id="3" name="Notes Placeholder 2"/>
+          <p:cNvSpPr>
+            <a:spLocks noGrp="1"/>
+          </p:cNvSpPr>
+          <p:nvPr>
+            <p:ph type="body" idx="1"/>
+          </p:nvPr>
+        </p:nvSpPr>
+        <p:spPr/>
+        <p:txBody>
+          <a:bodyPr/>
+          <a:lstStyle/>
+          <a:p>
+            <a:r>
+              <a:rPr lang="en-US" dirty="0"/>
+              <a:t/>
+            </a:r>
+            <a:endParaRPr lang="en-US" dirty="0"/>
+          </a:p>
+        </p:txBody>
+      </p:sp>
+      <p:sp>
+        <p:nvSpPr>
+          <p:cNvPr id="4" name="Slide Number Placeholder 3"/>
+          <p:cNvSpPr>
+            <a:spLocks noGrp="1"/>
+          </p:cNvSpPr>
+          <p:nvPr>
+            <p:ph type="sldNum" sz="quarter" idx="10"/>
+          </p:nvPr>
+        </p:nvSpPr>
+        <p:spPr/>
+        <p:txBody>
+          <a:bodyPr/>
+          <a:lstStyle/>
+          <a:p>
+            <a:fld id="{F7021451-1387-4CA6-816F-3879F97B5CBC}" type="slidenum">
+              <a:rPr lang="en-US"/>
+              <a:t>7</a:t>
+            </a:fld>
+            <a:endParaRPr lang="en-US"/>
+          </a:p>
+        </p:txBody>
+      </p:sp>
+    </p:spTree>
+    <p:extLst>
+      <p:ext uri="{BB962C8B-B14F-4D97-AF65-F5344CB8AC3E}">
+        <p14:creationId xmlns:p14="http://schemas.microsoft.com/office/powerpoint/2010/main" val="1024086991"/>
+      </p:ext>
+    </p:extLst>
+  </p:cSld>
+  <p:clrMapOvr>
+    <a:masterClrMapping/>
+  </p:clrMapOvr>
+</p:notes>
+</file>
+
+<file path=ppt/notesSlides/notesSlide8.xml><?xml version="1.0" encoding="utf-8"?>
+<p:notes xmlns:a="http://schemas.openxmlformats.org/drawingml/2006/main" xmlns:r="http://schemas.openxmlformats.org/officeDocument/2006/relationships" xmlns:p="http://schemas.openxmlformats.org/presentationml/2006/main">
+  <p:cSld>
+    <p:spTree>
+      <p:nvGrpSpPr>
+        <p:cNvPr id="1" name=""/>
+        <p:cNvGrpSpPr/>
+        <p:nvPr/>
+      </p:nvGrpSpPr>
+      <p:grpSpPr>
+        <a:xfrm>
+          <a:off x="0" y="0"/>
+          <a:ext cx="0" cy="0"/>
+          <a:chOff x="0" y="0"/>
+          <a:chExt cx="0" cy="0"/>
+        </a:xfrm>
+      </p:grpSpPr>
+      <p:sp>
+        <p:nvSpPr>
+          <p:cNvPr id="2" name="Slide Image Placeholder 1"/>
+          <p:cNvSpPr>
+            <a:spLocks noGrp="1" noRot="1" noChangeAspect="1"/>
+          </p:cNvSpPr>
+          <p:nvPr>
+            <p:ph type="sldImg"/>
+          </p:nvPr>
+        </p:nvSpPr>
+        <p:spPr/>
+      </p:sp>
+      <p:sp>
+        <p:nvSpPr>
+          <p:cNvPr id="3" name="Notes Placeholder 2"/>
+          <p:cNvSpPr>
+            <a:spLocks noGrp="1"/>
+          </p:cNvSpPr>
+          <p:nvPr>
+            <p:ph type="body" idx="1"/>
+          </p:nvPr>
+        </p:nvSpPr>
+        <p:spPr/>
+        <p:txBody>
+          <a:bodyPr/>
+          <a:lstStyle/>
+          <a:p>
+            <a:r>
+              <a:rPr lang="en-US" dirty="0"/>
+              <a:t/>
+            </a:r>
+            <a:endParaRPr lang="en-US" dirty="0"/>
+          </a:p>
+        </p:txBody>
+      </p:sp>
+      <p:sp>
+        <p:nvSpPr>
+          <p:cNvPr id="4" name="Slide Number Placeholder 3"/>
+          <p:cNvSpPr>
+            <a:spLocks noGrp="1"/>
+          </p:cNvSpPr>
+          <p:nvPr>
+            <p:ph type="sldNum" sz="quarter" idx="10"/>
+          </p:nvPr>
+        </p:nvSpPr>
+        <p:spPr/>
+        <p:txBody>
+          <a:bodyPr/>
+          <a:lstStyle/>
+          <a:p>
+            <a:fld id="{F7021451-1387-4CA6-816F-3879F97B5CBC}" type="slidenum">
+              <a:rPr lang="en-US"/>
+              <a:t>8</a:t>
+            </a:fld>
+            <a:endParaRPr lang="en-US"/>
+          </a:p>
+        </p:txBody>
+      </p:sp>
+    </p:spTree>
+    <p:extLst>
+      <p:ext uri="{BB962C8B-B14F-4D97-AF65-F5344CB8AC3E}">
+        <p14:creationId xmlns:p14="http://schemas.microsoft.com/office/powerpoint/2010/main" val="1024086991"/>
+      </p:ext>
+    </p:extLst>
+  </p:cSld>
+  <p:clrMapOvr>
+    <a:masterClrMapping/>
+  </p:clrMapOvr>
+</p:notes>
+</file>
+
 <file path=ppt/slideLayouts/slideLayout1.xml><?xml version="1.0" encoding="utf-8"?>
 <p:sldLayout xmlns:a="http://schemas.openxmlformats.org/drawingml/2006/main" xmlns:r="http://schemas.openxmlformats.org/officeDocument/2006/relationships" xmlns:p="http://schemas.openxmlformats.org/presentationml/2006/main" preserve="1">
   <p:cSld name="DEFAULT">
@@ -1210,13 +1477,6 @@
 <file path=ppt/slides/slide1.xml><?xml version="1.0" encoding="utf-8"?>
 <p:sld xmlns:a="http://schemas.openxmlformats.org/drawingml/2006/main" xmlns:r="http://schemas.openxmlformats.org/officeDocument/2006/relationships" xmlns:p="http://schemas.openxmlformats.org/presentationml/2006/main">
   <p:cSld name="Slide 1">
-    <p:bg>
-      <p:bgPr>
-        <a:solidFill>
-          <a:srgbClr val="1B2A4A"/>
-        </a:solidFill>
-      </p:bgPr>
-    </p:bg>
     <p:spTree>
       <p:nvGrpSpPr>
         <p:cNvPr id="1" name=""/>
@@ -1240,7 +1500,27 @@
         <p:spPr>
           <a:xfrm>
             <a:off x="0" y="0"/>
-            <a:ext cx="109728" cy="5143500"/>
+            <a:ext cx="9144000" cy="5143500"/>
+          </a:xfrm>
+          <a:prstGeom prst="rect">
+            <a:avLst/>
+          </a:prstGeom>
+          <a:solidFill>
+            <a:srgbClr val="1B2A4A"/>
+          </a:solidFill>
+          <a:ln/>
+        </p:spPr>
+      </p:sp>
+      <p:sp>
+        <p:nvSpPr>
+          <p:cNvPr id="3" name="Shape 1"/>
+          <p:cNvSpPr/>
+          <p:nvPr/>
+        </p:nvSpPr>
+        <p:spPr>
+          <a:xfrm>
+            <a:off x="0" y="4777740"/>
+            <a:ext cx="9144000" cy="365760"/>
           </a:xfrm>
           <a:prstGeom prst="rect">
             <a:avLst/>
@@ -1253,14 +1533,14 @@
       </p:sp>
       <p:sp>
         <p:nvSpPr>
-          <p:cNvPr id="3" name="Text 1"/>
+          <p:cNvPr id="4" name="Text 2"/>
           <p:cNvSpPr/>
           <p:nvPr/>
         </p:nvSpPr>
         <p:spPr>
           <a:xfrm>
             <a:off x="731520" y="1097280"/>
-            <a:ext cx="7772400" cy="1371600"/>
+            <a:ext cx="7680960" cy="457200"/>
           </a:xfrm>
           <a:prstGeom prst="rect">
             <a:avLst/>
@@ -1270,6 +1550,45 @@
         </p:spPr>
         <p:txBody>
           <a:bodyPr wrap="square" rtlCol="0" anchor="ctr"/>
+          <a:lstStyle/>
+          <a:p>
+            <a:pPr indent="0" marL="0">
+              <a:buNone/>
+            </a:pPr>
+            <a:r>
+              <a:rPr lang="en-US" sz="1400" b="1" spc="400" kern="0" dirty="0">
+                <a:solidFill>
+                  <a:srgbClr val="2A9D8F"/>
+                </a:solidFill>
+                <a:latin typeface="Calibri" pitchFamily="34" charset="0"/>
+                <a:ea typeface="Calibri" pitchFamily="34" charset="-122"/>
+                <a:cs typeface="Calibri" pitchFamily="34" charset="-120"/>
+              </a:rPr>
+              <a:t>GRADE 6 SCIENCE</a:t>
+            </a:r>
+            <a:endParaRPr lang="en-US" sz="1400" dirty="0"/>
+          </a:p>
+        </p:txBody>
+      </p:sp>
+      <p:sp>
+        <p:nvSpPr>
+          <p:cNvPr id="5" name="Text 3"/>
+          <p:cNvSpPr/>
+          <p:nvPr/>
+        </p:nvSpPr>
+        <p:spPr>
+          <a:xfrm>
+            <a:off x="731520" y="1645920"/>
+            <a:ext cx="7680960" cy="1463040"/>
+          </a:xfrm>
+          <a:prstGeom prst="rect">
+            <a:avLst/>
+          </a:prstGeom>
+          <a:noFill/>
+          <a:ln/>
+        </p:spPr>
+        <p:txBody>
+          <a:bodyPr wrap="square" rtlCol="0" anchor="t"/>
           <a:lstStyle/>
           <a:p>
             <a:pPr indent="0" marL="0">
@@ -1292,14 +1611,14 @@
       </p:sp>
       <p:sp>
         <p:nvSpPr>
-          <p:cNvPr id="4" name="Text 2"/>
-          <p:cNvSpPr/>
-          <p:nvPr/>
-        </p:nvSpPr>
-        <p:spPr>
-          <a:xfrm>
-            <a:off x="731520" y="2560320"/>
-            <a:ext cx="7772400" cy="548640"/>
+          <p:cNvPr id="6" name="Text 4"/>
+          <p:cNvSpPr/>
+          <p:nvPr/>
+        </p:nvSpPr>
+        <p:spPr>
+          <a:xfrm>
+            <a:off x="731520" y="3200400"/>
+            <a:ext cx="7680960" cy="548640"/>
           </a:xfrm>
           <a:prstGeom prst="rect">
             <a:avLst/>
@@ -1315,15 +1634,15 @@
               <a:buNone/>
             </a:pPr>
             <a:r>
-              <a:rPr lang="en-US" sz="1600" dirty="0">
-                <a:solidFill>
-                  <a:srgbClr val="E9C46A"/>
-                </a:solidFill>
-                <a:latin typeface="Calibri" pitchFamily="34" charset="0"/>
-                <a:ea typeface="Calibri" pitchFamily="34" charset="-122"/>
-                <a:cs typeface="Calibri" pitchFamily="34" charset="-120"/>
-              </a:rPr>
-              <a:t>Grade 6 Science · Mr Zocchi</a:t>
+              <a:rPr lang="en-US" sz="1600" i="1" dirty="0">
+                <a:solidFill>
+                  <a:srgbClr val="9B9690"/>
+                </a:solidFill>
+                <a:latin typeface="Calibri" pitchFamily="34" charset="0"/>
+                <a:ea typeface="Calibri" pitchFamily="34" charset="-122"/>
+                <a:cs typeface="Calibri" pitchFamily="34" charset="-120"/>
+              </a:rPr>
+              <a:t>How organisms survive in their habitat</a:t>
             </a:r>
             <a:endParaRPr lang="en-US" sz="1600" dirty="0"/>
           </a:p>
@@ -1331,36 +1650,14 @@
       </p:sp>
       <p:sp>
         <p:nvSpPr>
-          <p:cNvPr id="5" name="Shape 3"/>
-          <p:cNvSpPr/>
-          <p:nvPr/>
-        </p:nvSpPr>
-        <p:spPr>
-          <a:xfrm>
-            <a:off x="731520" y="3474720"/>
-            <a:ext cx="2011680" cy="411480"/>
-          </a:xfrm>
-          <a:prstGeom prst="roundRect">
-            <a:avLst>
-              <a:gd name="adj" fmla="val 17778"/>
-            </a:avLst>
-          </a:prstGeom>
-          <a:solidFill>
-            <a:srgbClr val="2A9D8F"/>
-          </a:solidFill>
-          <a:ln/>
-        </p:spPr>
-      </p:sp>
-      <p:sp>
-        <p:nvSpPr>
-          <p:cNvPr id="6" name="Text 4"/>
-          <p:cNvSpPr/>
-          <p:nvPr/>
-        </p:nvSpPr>
-        <p:spPr>
-          <a:xfrm>
-            <a:off x="731520" y="3474720"/>
-            <a:ext cx="2011680" cy="411480"/>
+          <p:cNvPr id="7" name="Text 5"/>
+          <p:cNvSpPr/>
+          <p:nvPr/>
+        </p:nvSpPr>
+        <p:spPr>
+          <a:xfrm>
+            <a:off x="731520" y="4206240"/>
+            <a:ext cx="3657600" cy="365760"/>
           </a:xfrm>
           <a:prstGeom prst="rect">
             <a:avLst/>
@@ -1372,19 +1669,19 @@
           <a:bodyPr wrap="square" rtlCol="0" anchor="ctr"/>
           <a:lstStyle/>
           <a:p>
-            <a:pPr algn="ctr" indent="0" marL="0">
+            <a:pPr indent="0" marL="0">
               <a:buNone/>
             </a:pPr>
             <a:r>
-              <a:rPr lang="en-US" sz="1200" b="1" dirty="0">
-                <a:solidFill>
-                  <a:srgbClr val="FFFFFF"/>
-                </a:solidFill>
-                <a:latin typeface="Calibri" pitchFamily="34" charset="0"/>
-                <a:ea typeface="Calibri" pitchFamily="34" charset="-122"/>
-                <a:cs typeface="Calibri" pitchFamily="34" charset="-120"/>
-              </a:rPr>
-              <a:t>Term 4 · Ecology</a:t>
+              <a:rPr lang="en-US" sz="1200" dirty="0">
+                <a:solidFill>
+                  <a:srgbClr val="6B6660"/>
+                </a:solidFill>
+                <a:latin typeface="Calibri" pitchFamily="34" charset="0"/>
+                <a:ea typeface="Calibri" pitchFamily="34" charset="-122"/>
+                <a:cs typeface="Calibri" pitchFamily="34" charset="-120"/>
+              </a:rPr>
+              <a:t>Mr Zocchi</a:t>
             </a:r>
             <a:endParaRPr lang="en-US" sz="1200" dirty="0"/>
           </a:p>
@@ -1401,13 +1698,6 @@
 <file path=ppt/slides/slide2.xml><?xml version="1.0" encoding="utf-8"?>
 <p:sld xmlns:a="http://schemas.openxmlformats.org/drawingml/2006/main" xmlns:r="http://schemas.openxmlformats.org/officeDocument/2006/relationships" xmlns:p="http://schemas.openxmlformats.org/presentationml/2006/main">
   <p:cSld name="Slide 2">
-    <p:bg>
-      <p:bgPr>
-        <a:solidFill>
-          <a:srgbClr val="FAF8F5"/>
-        </a:solidFill>
-      </p:bgPr>
-    </p:bg>
     <p:spTree>
       <p:nvGrpSpPr>
         <p:cNvPr id="1" name=""/>
@@ -1431,13 +1721,13 @@
         <p:spPr>
           <a:xfrm>
             <a:off x="0" y="0"/>
-            <a:ext cx="9144000" cy="54864"/>
-          </a:xfrm>
-          <a:prstGeom prst="rect">
-            <a:avLst/>
-          </a:prstGeom>
-          <a:solidFill>
-            <a:srgbClr val="2A9D8F"/>
+            <a:ext cx="9144000" cy="5143500"/>
+          </a:xfrm>
+          <a:prstGeom prst="rect">
+            <a:avLst/>
+          </a:prstGeom>
+          <a:solidFill>
+            <a:srgbClr val="111D35"/>
           </a:solidFill>
           <a:ln/>
         </p:spPr>
@@ -1450,8 +1740,8 @@
         </p:nvSpPr>
         <p:spPr>
           <a:xfrm>
-            <a:off x="7772400" y="4709160"/>
-            <a:ext cx="1097280" cy="320040"/>
+            <a:off x="6858000" y="182880"/>
+            <a:ext cx="2286000" cy="2743200"/>
           </a:xfrm>
           <a:prstGeom prst="rect">
             <a:avLst/>
@@ -1463,125 +1753,36 @@
           <a:bodyPr wrap="square" rtlCol="0" anchor="ctr"/>
           <a:lstStyle/>
           <a:p>
-            <a:pPr algn="r" indent="0" marL="0">
+            <a:pPr algn="ctr" indent="0" marL="0">
               <a:buNone/>
             </a:pPr>
             <a:r>
-              <a:rPr lang="en-US" sz="900" dirty="0">
-                <a:solidFill>
-                  <a:srgbClr val="6B6660"/>
-                </a:solidFill>
-                <a:latin typeface="Calibri" pitchFamily="34" charset="0"/>
-                <a:ea typeface="Calibri" pitchFamily="34" charset="-122"/>
-                <a:cs typeface="Calibri" pitchFamily="34" charset="-120"/>
-              </a:rPr>
-              <a:t>2 / 5</a:t>
-            </a:r>
-            <a:endParaRPr lang="en-US" sz="900" dirty="0"/>
-          </a:p>
-        </p:txBody>
-      </p:sp>
-      <p:sp>
-        <p:nvSpPr>
-          <p:cNvPr id="4" name="Shape 2"/>
-          <p:cNvSpPr/>
-          <p:nvPr/>
-        </p:nvSpPr>
-        <p:spPr>
-          <a:xfrm>
-            <a:off x="1371600" y="914400"/>
-            <a:ext cx="6400800" cy="3200400"/>
-          </a:xfrm>
-          <a:prstGeom prst="rect">
-            <a:avLst/>
-          </a:prstGeom>
-          <a:solidFill>
-            <a:srgbClr val="FFFFFF"/>
-          </a:solidFill>
-          <a:ln w="12700">
-            <a:solidFill>
-              <a:srgbClr val="E5E2DC"/>
-            </a:solidFill>
-            <a:prstDash val="solid"/>
-          </a:ln>
-          <a:effectLst>
-            <a:outerShdw sx="100000" sy="100000" kx="0" ky="0" algn="bl" rotWithShape="0" blurRad="50800" dist="25400" dir="8100000">
-              <a:srgbClr val="000000">
-                <a:alpha val="10000"/>
-              </a:srgbClr>
-            </a:outerShdw>
-          </a:effectLst>
-        </p:spPr>
-      </p:sp>
-      <p:sp>
-        <p:nvSpPr>
-          <p:cNvPr id="5" name="Shape 3"/>
-          <p:cNvSpPr/>
-          <p:nvPr/>
-        </p:nvSpPr>
-        <p:spPr>
-          <a:xfrm>
-            <a:off x="1371600" y="914400"/>
-            <a:ext cx="91440" cy="3200400"/>
-          </a:xfrm>
-          <a:prstGeom prst="rect">
-            <a:avLst/>
-          </a:prstGeom>
-          <a:solidFill>
-            <a:srgbClr val="2A9D8F"/>
-          </a:solidFill>
-          <a:ln/>
-        </p:spPr>
-      </p:sp>
-      <p:sp>
-        <p:nvSpPr>
-          <p:cNvPr id="6" name="Text 4"/>
-          <p:cNvSpPr/>
-          <p:nvPr/>
-        </p:nvSpPr>
-        <p:spPr>
-          <a:xfrm>
-            <a:off x="1828800" y="1097280"/>
-            <a:ext cx="5669280" cy="640080"/>
-          </a:xfrm>
-          <a:prstGeom prst="rect">
-            <a:avLst/>
-          </a:prstGeom>
-          <a:noFill/>
-          <a:ln/>
-        </p:spPr>
-        <p:txBody>
-          <a:bodyPr wrap="square" rtlCol="0" anchor="ctr"/>
-          <a:lstStyle/>
-          <a:p>
-            <a:pPr indent="0" marL="0">
-              <a:buNone/>
-            </a:pPr>
-            <a:r>
-              <a:rPr lang="en-US" sz="2400" b="1" dirty="0">
-                <a:solidFill>
-                  <a:srgbClr val="1B2A4A"/>
+              <a:rPr lang="en-US" sz="16000" b="1" dirty="0">
+                <a:solidFill>
+                  <a:srgbClr val="2A9D8F">
+                    <a:alpha val="80000"/>
+                  </a:srgbClr>
                 </a:solidFill>
                 <a:latin typeface="Georgia" pitchFamily="34" charset="0"/>
                 <a:ea typeface="Georgia" pitchFamily="34" charset="-122"/>
                 <a:cs typeface="Georgia" pitchFamily="34" charset="-120"/>
               </a:rPr>
-              <a:t>Surviving in Your Environment</a:t>
-            </a:r>
-            <a:endParaRPr lang="en-US" sz="2400" dirty="0"/>
-          </a:p>
-        </p:txBody>
-      </p:sp>
-      <p:sp>
-        <p:nvSpPr>
-          <p:cNvPr id="7" name="Text 5"/>
-          <p:cNvSpPr/>
-          <p:nvPr/>
-        </p:nvSpPr>
-        <p:spPr>
-          <a:xfrm>
-            <a:off x="1828800" y="1828800"/>
-            <a:ext cx="5669280" cy="2011680"/>
+              <a:t>?</a:t>
+            </a:r>
+            <a:endParaRPr lang="en-US" sz="16000" dirty="0"/>
+          </a:p>
+        </p:txBody>
+      </p:sp>
+      <p:sp>
+        <p:nvSpPr>
+          <p:cNvPr id="4" name="Text 2"/>
+          <p:cNvSpPr/>
+          <p:nvPr/>
+        </p:nvSpPr>
+        <p:spPr>
+          <a:xfrm>
+            <a:off x="731520" y="548640"/>
+            <a:ext cx="2743200" cy="365760"/>
           </a:xfrm>
           <a:prstGeom prst="rect">
             <a:avLst/>
@@ -1590,27 +1791,246 @@
           <a:ln/>
         </p:spPr>
         <p:txBody>
+          <a:bodyPr wrap="square" rtlCol="0" anchor="ctr"/>
+          <a:lstStyle/>
+          <a:p>
+            <a:pPr indent="0" marL="0">
+              <a:buNone/>
+            </a:pPr>
+            <a:r>
+              <a:rPr lang="en-US" sz="1200" b="1" spc="400" kern="0" dirty="0">
+                <a:solidFill>
+                  <a:srgbClr val="2A9D8F"/>
+                </a:solidFill>
+                <a:latin typeface="Calibri" pitchFamily="34" charset="0"/>
+                <a:ea typeface="Calibri" pitchFamily="34" charset="-122"/>
+                <a:cs typeface="Calibri" pitchFamily="34" charset="-120"/>
+              </a:rPr>
+              <a:t>INQUIRY</a:t>
+            </a:r>
+            <a:endParaRPr lang="en-US" sz="1200" dirty="0"/>
+          </a:p>
+        </p:txBody>
+      </p:sp>
+      <p:sp>
+        <p:nvSpPr>
+          <p:cNvPr id="5" name="Text 3"/>
+          <p:cNvSpPr/>
+          <p:nvPr/>
+        </p:nvSpPr>
+        <p:spPr>
+          <a:xfrm>
+            <a:off x="731520" y="1005840"/>
+            <a:ext cx="6858000" cy="1463040"/>
+          </a:xfrm>
+          <a:prstGeom prst="rect">
+            <a:avLst/>
+          </a:prstGeom>
+          <a:noFill/>
+          <a:ln/>
+        </p:spPr>
+        <p:txBody>
           <a:bodyPr wrap="square" rtlCol="0" anchor="t"/>
           <a:lstStyle/>
           <a:p>
             <a:pPr indent="0" marL="0">
-              <a:lnSpc>
-                <a:spcPct val="130000"/>
-              </a:lnSpc>
               <a:buNone/>
             </a:pPr>
             <a:r>
-              <a:rPr lang="en-US" sz="1500" dirty="0">
-                <a:solidFill>
-                  <a:srgbClr val="3D3A36"/>
-                </a:solidFill>
-                <a:latin typeface="Calibri" pitchFamily="34" charset="0"/>
-                <a:ea typeface="Calibri" pitchFamily="34" charset="-122"/>
-                <a:cs typeface="Calibri" pitchFamily="34" charset="-120"/>
-              </a:rPr>
-              <a:t>An adaptation is a feature that helps an organism survive in its habitat. Adaptations develop over many generations through natural selection. Organisms that are better adapted are more likely to survive, reproduce, and pass on their features.</a:t>
-            </a:r>
-            <a:endParaRPr lang="en-US" sz="1500" dirty="0"/>
+              <a:rPr lang="en-US" sz="2800" b="1" dirty="0">
+                <a:solidFill>
+                  <a:srgbClr val="FFFFFF"/>
+                </a:solidFill>
+                <a:latin typeface="Georgia" pitchFamily="34" charset="0"/>
+                <a:ea typeface="Georgia" pitchFamily="34" charset="-122"/>
+                <a:cs typeface="Georgia" pitchFamily="34" charset="-120"/>
+              </a:rPr>
+              <a:t>Giant pandas only eat bamboo, but bamboo has almost no nutritional value. How have pandas adapted to survive on such a poor diet?</a:t>
+            </a:r>
+            <a:endParaRPr lang="en-US" sz="2800" dirty="0"/>
+          </a:p>
+        </p:txBody>
+      </p:sp>
+      <p:sp>
+        <p:nvSpPr>
+          <p:cNvPr id="6" name="Text 4"/>
+          <p:cNvSpPr/>
+          <p:nvPr/>
+        </p:nvSpPr>
+        <p:spPr>
+          <a:xfrm>
+            <a:off x="731520" y="2560320"/>
+            <a:ext cx="6858000" cy="548640"/>
+          </a:xfrm>
+          <a:prstGeom prst="rect">
+            <a:avLst/>
+          </a:prstGeom>
+          <a:noFill/>
+          <a:ln/>
+        </p:spPr>
+        <p:txBody>
+          <a:bodyPr wrap="square" rtlCol="0" anchor="ctr"/>
+          <a:lstStyle/>
+          <a:p>
+            <a:pPr indent="0" marL="0">
+              <a:buNone/>
+            </a:pPr>
+            <a:r>
+              <a:rPr lang="en-US" sz="1400" i="1" dirty="0">
+                <a:solidFill>
+                  <a:srgbClr val="9B9690"/>
+                </a:solidFill>
+                <a:latin typeface="Calibri" pitchFamily="34" charset="0"/>
+                <a:ea typeface="Calibri" pitchFamily="34" charset="-122"/>
+                <a:cs typeface="Calibri" pitchFamily="34" charset="-120"/>
+              </a:rPr>
+              <a:t>Every organism is shaped by its environment — adaptations are the result of millions of years of natural selection.</a:t>
+            </a:r>
+            <a:endParaRPr lang="en-US" sz="1400" dirty="0"/>
+          </a:p>
+        </p:txBody>
+      </p:sp>
+      <p:sp>
+        <p:nvSpPr>
+          <p:cNvPr id="7" name="Shape 5"/>
+          <p:cNvSpPr/>
+          <p:nvPr/>
+        </p:nvSpPr>
+        <p:spPr>
+          <a:xfrm>
+            <a:off x="548640" y="3200400"/>
+            <a:ext cx="7315200" cy="1645920"/>
+          </a:xfrm>
+          <a:prstGeom prst="rect">
+            <a:avLst/>
+          </a:prstGeom>
+          <a:solidFill>
+            <a:srgbClr val="243660"/>
+          </a:solidFill>
+          <a:ln/>
+        </p:spPr>
+      </p:sp>
+      <p:sp>
+        <p:nvSpPr>
+          <p:cNvPr id="8" name="Text 6"/>
+          <p:cNvSpPr/>
+          <p:nvPr/>
+        </p:nvSpPr>
+        <p:spPr>
+          <a:xfrm>
+            <a:off x="731520" y="3246120"/>
+            <a:ext cx="3657600" cy="320040"/>
+          </a:xfrm>
+          <a:prstGeom prst="rect">
+            <a:avLst/>
+          </a:prstGeom>
+          <a:noFill/>
+          <a:ln/>
+        </p:spPr>
+        <p:txBody>
+          <a:bodyPr wrap="square" rtlCol="0" anchor="ctr"/>
+          <a:lstStyle/>
+          <a:p>
+            <a:pPr indent="0" marL="0">
+              <a:buNone/>
+            </a:pPr>
+            <a:r>
+              <a:rPr lang="en-US" sz="1100" b="1" spc="200" kern="0" dirty="0">
+                <a:solidFill>
+                  <a:srgbClr val="2A9D8F"/>
+                </a:solidFill>
+                <a:latin typeface="Calibri" pitchFamily="34" charset="0"/>
+                <a:ea typeface="Calibri" pitchFamily="34" charset="-122"/>
+                <a:cs typeface="Calibri" pitchFamily="34" charset="-120"/>
+              </a:rPr>
+              <a:t>Think — Pair — Share</a:t>
+            </a:r>
+            <a:endParaRPr lang="en-US" sz="1100" dirty="0"/>
+          </a:p>
+        </p:txBody>
+      </p:sp>
+      <p:sp>
+        <p:nvSpPr>
+          <p:cNvPr id="9" name="Text 7"/>
+          <p:cNvSpPr/>
+          <p:nvPr/>
+        </p:nvSpPr>
+        <p:spPr>
+          <a:xfrm>
+            <a:off x="731520" y="3566160"/>
+            <a:ext cx="6949440" cy="1188720"/>
+          </a:xfrm>
+          <a:prstGeom prst="rect">
+            <a:avLst/>
+          </a:prstGeom>
+          <a:noFill/>
+          <a:ln/>
+        </p:spPr>
+        <p:txBody>
+          <a:bodyPr wrap="square" rtlCol="0" anchor="ctr"/>
+          <a:lstStyle/>
+          <a:p>
+            <a:pPr marL="342900" indent="-342900">
+              <a:spcAft>
+                <a:spcPts val="600"/>
+              </a:spcAft>
+              <a:buSzPct val="100000"/>
+              <a:buChar char="•"/>
+            </a:pPr>
+            <a:r>
+              <a:rPr lang="en-US" sz="1400" dirty="0">
+                <a:solidFill>
+                  <a:srgbClr val="E5E2DC"/>
+                </a:solidFill>
+                <a:latin typeface="Calibri" pitchFamily="34" charset="0"/>
+                <a:ea typeface="Calibri" pitchFamily="34" charset="-122"/>
+                <a:cs typeface="Calibri" pitchFamily="34" charset="-120"/>
+              </a:rPr>
+              <a:t>What structural adaptations help pandas eat bamboo?</a:t>
+            </a:r>
+            <a:endParaRPr lang="en-US" sz="1400" dirty="0"/>
+          </a:p>
+          <a:p>
+            <a:pPr marL="342900" indent="-342900">
+              <a:spcAft>
+                <a:spcPts val="600"/>
+              </a:spcAft>
+              <a:buSzPct val="100000"/>
+              <a:buChar char="•"/>
+            </a:pPr>
+            <a:r>
+              <a:rPr lang="en-US" sz="1400" dirty="0">
+                <a:solidFill>
+                  <a:srgbClr val="E5E2DC"/>
+                </a:solidFill>
+                <a:latin typeface="Calibri" pitchFamily="34" charset="0"/>
+                <a:ea typeface="Calibri" pitchFamily="34" charset="-122"/>
+                <a:cs typeface="Calibri" pitchFamily="34" charset="-120"/>
+              </a:rPr>
+              <a:t>Why can't pandas survive in a German forest?</a:t>
+            </a:r>
+            <a:endParaRPr lang="en-US" sz="1400" dirty="0"/>
+          </a:p>
+          <a:p>
+            <a:pPr marL="342900" indent="-342900">
+              <a:spcAft>
+                <a:spcPts val="600"/>
+              </a:spcAft>
+              <a:buSzPct val="100000"/>
+              <a:buChar char="•"/>
+            </a:pPr>
+            <a:r>
+              <a:rPr lang="en-US" sz="1400" dirty="0">
+                <a:solidFill>
+                  <a:srgbClr val="E5E2DC"/>
+                </a:solidFill>
+                <a:latin typeface="Calibri" pitchFamily="34" charset="0"/>
+                <a:ea typeface="Calibri" pitchFamily="34" charset="-122"/>
+                <a:cs typeface="Calibri" pitchFamily="34" charset="-120"/>
+              </a:rPr>
+              <a:t>What would happen if all the bamboo disappeared?</a:t>
+            </a:r>
+            <a:endParaRPr lang="en-US" sz="1400" dirty="0"/>
           </a:p>
         </p:txBody>
       </p:sp>
@@ -1655,7 +2075,27 @@
         <p:spPr>
           <a:xfrm>
             <a:off x="0" y="0"/>
-            <a:ext cx="9144000" cy="54864"/>
+            <a:ext cx="9144000" cy="822960"/>
+          </a:xfrm>
+          <a:prstGeom prst="rect">
+            <a:avLst/>
+          </a:prstGeom>
+          <a:solidFill>
+            <a:srgbClr val="FFFFFF"/>
+          </a:solidFill>
+          <a:ln/>
+        </p:spPr>
+      </p:sp>
+      <p:sp>
+        <p:nvSpPr>
+          <p:cNvPr id="3" name="Shape 1"/>
+          <p:cNvSpPr/>
+          <p:nvPr/>
+        </p:nvSpPr>
+        <p:spPr>
+          <a:xfrm>
+            <a:off x="0" y="795528"/>
+            <a:ext cx="9144000" cy="27432"/>
           </a:xfrm>
           <a:prstGeom prst="rect">
             <a:avLst/>
@@ -1668,14 +2108,14 @@
       </p:sp>
       <p:sp>
         <p:nvSpPr>
-          <p:cNvPr id="3" name="Text 1"/>
-          <p:cNvSpPr/>
-          <p:nvPr/>
-        </p:nvSpPr>
-        <p:spPr>
-          <a:xfrm>
-            <a:off x="7772400" y="4709160"/>
-            <a:ext cx="1097280" cy="320040"/>
+          <p:cNvPr id="4" name="Text 2"/>
+          <p:cNvSpPr/>
+          <p:nvPr/>
+        </p:nvSpPr>
+        <p:spPr>
+          <a:xfrm>
+            <a:off x="640080" y="91440"/>
+            <a:ext cx="7863840" cy="640080"/>
           </a:xfrm>
           <a:prstGeom prst="rect">
             <a:avLst/>
@@ -1684,53 +2124,14 @@
           <a:ln/>
         </p:spPr>
         <p:txBody>
-          <a:bodyPr wrap="square" rtlCol="0" anchor="ctr"/>
-          <a:lstStyle/>
-          <a:p>
-            <a:pPr algn="r" indent="0" marL="0">
-              <a:buNone/>
-            </a:pPr>
-            <a:r>
-              <a:rPr lang="en-US" sz="900" dirty="0">
-                <a:solidFill>
-                  <a:srgbClr val="6B6660"/>
-                </a:solidFill>
-                <a:latin typeface="Calibri" pitchFamily="34" charset="0"/>
-                <a:ea typeface="Calibri" pitchFamily="34" charset="-122"/>
-                <a:cs typeface="Calibri" pitchFamily="34" charset="-120"/>
-              </a:rPr>
-              <a:t>3 / 5</a:t>
-            </a:r>
-            <a:endParaRPr lang="en-US" sz="900" dirty="0"/>
-          </a:p>
-        </p:txBody>
-      </p:sp>
-      <p:sp>
-        <p:nvSpPr>
-          <p:cNvPr id="4" name="Text 2"/>
-          <p:cNvSpPr/>
-          <p:nvPr/>
-        </p:nvSpPr>
-        <p:spPr>
-          <a:xfrm>
-            <a:off x="457200" y="274320"/>
-            <a:ext cx="8229600" cy="640080"/>
-          </a:xfrm>
-          <a:prstGeom prst="rect">
-            <a:avLst/>
-          </a:prstGeom>
-          <a:noFill/>
-          <a:ln/>
-        </p:spPr>
-        <p:txBody>
-          <a:bodyPr wrap="square" rtlCol="0" anchor="ctr"/>
+          <a:bodyPr wrap="square" lIns="0" tIns="0" rIns="0" bIns="0" rtlCol="0" anchor="ctr"/>
           <a:lstStyle/>
           <a:p>
             <a:pPr indent="0" marL="0">
               <a:buNone/>
             </a:pPr>
             <a:r>
-              <a:rPr lang="en-US" sz="2600" b="1" dirty="0">
+              <a:rPr lang="en-US" sz="2200" b="1" dirty="0">
                 <a:solidFill>
                   <a:srgbClr val="1B2A4A"/>
                 </a:solidFill>
@@ -1738,39 +2139,161 @@
                 <a:ea typeface="Georgia" pitchFamily="34" charset="-122"/>
                 <a:cs typeface="Georgia" pitchFamily="34" charset="-120"/>
               </a:rPr>
-              <a:t>Three Types of Adaptation</a:t>
-            </a:r>
-            <a:endParaRPr lang="en-US" sz="2600" dirty="0"/>
-          </a:p>
-        </p:txBody>
-      </p:sp>
-      <p:sp>
-        <p:nvSpPr>
-          <p:cNvPr id="5" name="Shape 3"/>
-          <p:cNvSpPr/>
-          <p:nvPr/>
-        </p:nvSpPr>
-        <p:spPr>
-          <a:xfrm>
-            <a:off x="457200" y="1188720"/>
-            <a:ext cx="2560320" cy="1828800"/>
-          </a:xfrm>
-          <a:prstGeom prst="rect">
-            <a:avLst/>
-          </a:prstGeom>
-          <a:solidFill>
-            <a:srgbClr val="FFFFFF"/>
-          </a:solidFill>
-          <a:ln w="12700">
-            <a:solidFill>
-              <a:srgbClr val="E5E2DC"/>
-            </a:solidFill>
-            <a:prstDash val="solid"/>
-          </a:ln>
+              <a:t>What Is an Adaptation?</a:t>
+            </a:r>
+            <a:endParaRPr lang="en-US" sz="2200" dirty="0"/>
+          </a:p>
+        </p:txBody>
+      </p:sp>
+      <p:sp>
+        <p:nvSpPr>
+          <p:cNvPr id="5" name="Text 3"/>
+          <p:cNvSpPr/>
+          <p:nvPr/>
+        </p:nvSpPr>
+        <p:spPr>
+          <a:xfrm>
+            <a:off x="640080" y="1005840"/>
+            <a:ext cx="7863840" cy="2926080"/>
+          </a:xfrm>
+          <a:prstGeom prst="rect">
+            <a:avLst/>
+          </a:prstGeom>
+          <a:noFill/>
+          <a:ln/>
+        </p:spPr>
+        <p:txBody>
+          <a:bodyPr wrap="square" rtlCol="0" anchor="ctr"/>
+          <a:lstStyle/>
+          <a:p>
+            <a:pPr marL="342900" indent="-342900">
+              <a:spcAft>
+                <a:spcPts val="800"/>
+              </a:spcAft>
+              <a:buSzPct val="100000"/>
+              <a:buChar char="•"/>
+            </a:pPr>
+            <a:r>
+              <a:rPr lang="en-US" sz="1600" dirty="0">
+                <a:solidFill>
+                  <a:srgbClr val="3D3A36"/>
+                </a:solidFill>
+                <a:latin typeface="Calibri" pitchFamily="34" charset="0"/>
+                <a:ea typeface="Calibri" pitchFamily="34" charset="-122"/>
+                <a:cs typeface="Calibri" pitchFamily="34" charset="-120"/>
+              </a:rPr>
+              <a:t>A feature that helps an organism survive in its habitat.</a:t>
+            </a:r>
+            <a:endParaRPr lang="en-US" sz="1600" dirty="0"/>
+          </a:p>
+          <a:p>
+            <a:pPr marL="342900" indent="-342900">
+              <a:spcAft>
+                <a:spcPts val="800"/>
+              </a:spcAft>
+              <a:buSzPct val="100000"/>
+              <a:buChar char="•"/>
+            </a:pPr>
+            <a:r>
+              <a:rPr lang="en-US" sz="1600" dirty="0">
+                <a:solidFill>
+                  <a:srgbClr val="3D3A36"/>
+                </a:solidFill>
+                <a:latin typeface="Calibri" pitchFamily="34" charset="0"/>
+                <a:ea typeface="Calibri" pitchFamily="34" charset="-122"/>
+                <a:cs typeface="Calibri" pitchFamily="34" charset="-120"/>
+              </a:rPr>
+              <a:t>Three types: structural, behavioural, functional.</a:t>
+            </a:r>
+            <a:endParaRPr lang="en-US" sz="1600" dirty="0"/>
+          </a:p>
+          <a:p>
+            <a:pPr marL="342900" indent="-342900">
+              <a:spcAft>
+                <a:spcPts val="800"/>
+              </a:spcAft>
+              <a:buSzPct val="100000"/>
+              <a:buChar char="•"/>
+            </a:pPr>
+            <a:r>
+              <a:rPr lang="en-US" sz="1600" dirty="0">
+                <a:solidFill>
+                  <a:srgbClr val="3D3A36"/>
+                </a:solidFill>
+                <a:latin typeface="Calibri" pitchFamily="34" charset="0"/>
+                <a:ea typeface="Calibri" pitchFamily="34" charset="-122"/>
+                <a:cs typeface="Calibri" pitchFamily="34" charset="-120"/>
+              </a:rPr>
+              <a:t>Structural: physical features (polar bear thick fur, cactus spines).</a:t>
+            </a:r>
+            <a:endParaRPr lang="en-US" sz="1600" dirty="0"/>
+          </a:p>
+          <a:p>
+            <a:pPr marL="342900" indent="-342900">
+              <a:spcAft>
+                <a:spcPts val="800"/>
+              </a:spcAft>
+              <a:buSzPct val="100000"/>
+              <a:buChar char="•"/>
+            </a:pPr>
+            <a:r>
+              <a:rPr lang="en-US" sz="1600" dirty="0">
+                <a:solidFill>
+                  <a:srgbClr val="3D3A36"/>
+                </a:solidFill>
+                <a:latin typeface="Calibri" pitchFamily="34" charset="0"/>
+                <a:ea typeface="Calibri" pitchFamily="34" charset="-122"/>
+                <a:cs typeface="Calibri" pitchFamily="34" charset="-120"/>
+              </a:rPr>
+              <a:t>Behavioural: actions (bird migration, nocturnal hunting).</a:t>
+            </a:r>
+            <a:endParaRPr lang="en-US" sz="1600" dirty="0"/>
+          </a:p>
+          <a:p>
+            <a:pPr marL="342900" indent="-342900">
+              <a:spcAft>
+                <a:spcPts val="800"/>
+              </a:spcAft>
+              <a:buSzPct val="100000"/>
+              <a:buChar char="•"/>
+            </a:pPr>
+            <a:r>
+              <a:rPr lang="en-US" sz="1600" dirty="0">
+                <a:solidFill>
+                  <a:srgbClr val="3D3A36"/>
+                </a:solidFill>
+                <a:latin typeface="Calibri" pitchFamily="34" charset="0"/>
+                <a:ea typeface="Calibri" pitchFamily="34" charset="-122"/>
+                <a:cs typeface="Calibri" pitchFamily="34" charset="-120"/>
+              </a:rPr>
+              <a:t>Functional: internal processes (desert animals concentrate urine).</a:t>
+            </a:r>
+            <a:endParaRPr lang="en-US" sz="1600" dirty="0"/>
+          </a:p>
+        </p:txBody>
+      </p:sp>
+      <p:sp>
+        <p:nvSpPr>
+          <p:cNvPr id="6" name="Shape 4"/>
+          <p:cNvSpPr/>
+          <p:nvPr/>
+        </p:nvSpPr>
+        <p:spPr>
+          <a:xfrm>
+            <a:off x="640080" y="4114800"/>
+            <a:ext cx="7863840" cy="731520"/>
+          </a:xfrm>
+          <a:prstGeom prst="rect">
+            <a:avLst/>
+          </a:prstGeom>
+          <a:solidFill>
+            <a:srgbClr val="E8F5F3"/>
+          </a:solidFill>
+          <a:ln/>
           <a:effectLst>
-            <a:outerShdw sx="100000" sy="100000" kx="0" ky="0" algn="bl" rotWithShape="0" blurRad="50800" dist="25400" dir="8100000">
+            <a:outerShdw sx="100000" sy="100000" kx="0" ky="0" algn="bl" rotWithShape="0" blurRad="76200" dist="25400" dir="8100000">
               <a:srgbClr val="000000">
-                <a:alpha val="10000"/>
+                <a:alpha val="12000"/>
               </a:srgbClr>
             </a:outerShdw>
           </a:effectLst>
@@ -1778,14 +2301,14 @@
       </p:sp>
       <p:sp>
         <p:nvSpPr>
-          <p:cNvPr id="6" name="Shape 4"/>
-          <p:cNvSpPr/>
-          <p:nvPr/>
-        </p:nvSpPr>
-        <p:spPr>
-          <a:xfrm>
-            <a:off x="457200" y="1188720"/>
-            <a:ext cx="2560320" cy="54864"/>
+          <p:cNvPr id="7" name="Shape 5"/>
+          <p:cNvSpPr/>
+          <p:nvPr/>
+        </p:nvSpPr>
+        <p:spPr>
+          <a:xfrm>
+            <a:off x="640080" y="4114800"/>
+            <a:ext cx="64008" cy="731520"/>
           </a:xfrm>
           <a:prstGeom prst="rect">
             <a:avLst/>
@@ -1798,14 +2321,14 @@
       </p:sp>
       <p:sp>
         <p:nvSpPr>
-          <p:cNvPr id="7" name="Text 5"/>
-          <p:cNvSpPr/>
-          <p:nvPr/>
-        </p:nvSpPr>
-        <p:spPr>
-          <a:xfrm>
-            <a:off x="594360" y="1325880"/>
-            <a:ext cx="2286000" cy="365760"/>
+          <p:cNvPr id="8" name="Text 6"/>
+          <p:cNvSpPr/>
+          <p:nvPr/>
+        </p:nvSpPr>
+        <p:spPr>
+          <a:xfrm>
+            <a:off x="914400" y="4160520"/>
+            <a:ext cx="7406640" cy="640080"/>
           </a:xfrm>
           <a:prstGeom prst="rect">
             <a:avLst/>
@@ -1821,46 +2344,7 @@
               <a:buNone/>
             </a:pPr>
             <a:r>
-              <a:rPr lang="en-US" sz="1400" b="1" dirty="0">
-                <a:solidFill>
-                  <a:srgbClr val="1B2A4A"/>
-                </a:solidFill>
-                <a:latin typeface="Calibri" pitchFamily="34" charset="0"/>
-                <a:ea typeface="Calibri" pitchFamily="34" charset="-122"/>
-                <a:cs typeface="Calibri" pitchFamily="34" charset="-120"/>
-              </a:rPr>
-              <a:t>Structural</a:t>
-            </a:r>
-            <a:endParaRPr lang="en-US" sz="1400" dirty="0"/>
-          </a:p>
-        </p:txBody>
-      </p:sp>
-      <p:sp>
-        <p:nvSpPr>
-          <p:cNvPr id="8" name="Text 6"/>
-          <p:cNvSpPr/>
-          <p:nvPr/>
-        </p:nvSpPr>
-        <p:spPr>
-          <a:xfrm>
-            <a:off x="594360" y="1737360"/>
-            <a:ext cx="2286000" cy="1097280"/>
-          </a:xfrm>
-          <a:prstGeom prst="rect">
-            <a:avLst/>
-          </a:prstGeom>
-          <a:noFill/>
-          <a:ln/>
-        </p:spPr>
-        <p:txBody>
-          <a:bodyPr wrap="square" rtlCol="0" anchor="t"/>
-          <a:lstStyle/>
-          <a:p>
-            <a:pPr indent="0" marL="0">
-              <a:buNone/>
-            </a:pPr>
-            <a:r>
-              <a:rPr lang="en-US" sz="1100" dirty="0">
+              <a:rPr lang="en-US" sz="1300" i="1" dirty="0">
                 <a:solidFill>
                   <a:srgbClr val="3D3A36"/>
                 </a:solidFill>
@@ -1868,269 +2352,9 @@
                 <a:ea typeface="Calibri" pitchFamily="34" charset="-122"/>
                 <a:cs typeface="Calibri" pitchFamily="34" charset="-120"/>
               </a:rPr>
-              <a:t>Physical features of the body. Thick fur (polar bear), long neck (giraffe), thorns (cactus), streamlined body (dolphin), webbed feet (duck).</a:t>
-            </a:r>
-            <a:endParaRPr lang="en-US" sz="1100" dirty="0"/>
-          </a:p>
-        </p:txBody>
-      </p:sp>
-      <p:sp>
-        <p:nvSpPr>
-          <p:cNvPr id="9" name="Shape 7"/>
-          <p:cNvSpPr/>
-          <p:nvPr/>
-        </p:nvSpPr>
-        <p:spPr>
-          <a:xfrm>
-            <a:off x="3291840" y="1188720"/>
-            <a:ext cx="2560320" cy="1828800"/>
-          </a:xfrm>
-          <a:prstGeom prst="rect">
-            <a:avLst/>
-          </a:prstGeom>
-          <a:solidFill>
-            <a:srgbClr val="FFFFFF"/>
-          </a:solidFill>
-          <a:ln w="12700">
-            <a:solidFill>
-              <a:srgbClr val="E5E2DC"/>
-            </a:solidFill>
-            <a:prstDash val="solid"/>
-          </a:ln>
-          <a:effectLst>
-            <a:outerShdw sx="100000" sy="100000" kx="0" ky="0" algn="bl" rotWithShape="0" blurRad="50800" dist="25400" dir="8100000">
-              <a:srgbClr val="000000">
-                <a:alpha val="10000"/>
-              </a:srgbClr>
-            </a:outerShdw>
-          </a:effectLst>
-        </p:spPr>
-      </p:sp>
-      <p:sp>
-        <p:nvSpPr>
-          <p:cNvPr id="10" name="Shape 8"/>
-          <p:cNvSpPr/>
-          <p:nvPr/>
-        </p:nvSpPr>
-        <p:spPr>
-          <a:xfrm>
-            <a:off x="3291840" y="1188720"/>
-            <a:ext cx="2560320" cy="54864"/>
-          </a:xfrm>
-          <a:prstGeom prst="rect">
-            <a:avLst/>
-          </a:prstGeom>
-          <a:solidFill>
-            <a:srgbClr val="2A9D8F"/>
-          </a:solidFill>
-          <a:ln/>
-        </p:spPr>
-      </p:sp>
-      <p:sp>
-        <p:nvSpPr>
-          <p:cNvPr id="11" name="Text 9"/>
-          <p:cNvSpPr/>
-          <p:nvPr/>
-        </p:nvSpPr>
-        <p:spPr>
-          <a:xfrm>
-            <a:off x="3429000" y="1325880"/>
-            <a:ext cx="2286000" cy="365760"/>
-          </a:xfrm>
-          <a:prstGeom prst="rect">
-            <a:avLst/>
-          </a:prstGeom>
-          <a:noFill/>
-          <a:ln/>
-        </p:spPr>
-        <p:txBody>
-          <a:bodyPr wrap="square" rtlCol="0" anchor="ctr"/>
-          <a:lstStyle/>
-          <a:p>
-            <a:pPr indent="0" marL="0">
-              <a:buNone/>
-            </a:pPr>
-            <a:r>
-              <a:rPr lang="en-US" sz="1400" b="1" dirty="0">
-                <a:solidFill>
-                  <a:srgbClr val="1B2A4A"/>
-                </a:solidFill>
-                <a:latin typeface="Calibri" pitchFamily="34" charset="0"/>
-                <a:ea typeface="Calibri" pitchFamily="34" charset="-122"/>
-                <a:cs typeface="Calibri" pitchFamily="34" charset="-120"/>
-              </a:rPr>
-              <a:t>Behavioural</a:t>
-            </a:r>
-            <a:endParaRPr lang="en-US" sz="1400" dirty="0"/>
-          </a:p>
-        </p:txBody>
-      </p:sp>
-      <p:sp>
-        <p:nvSpPr>
-          <p:cNvPr id="12" name="Text 10"/>
-          <p:cNvSpPr/>
-          <p:nvPr/>
-        </p:nvSpPr>
-        <p:spPr>
-          <a:xfrm>
-            <a:off x="3429000" y="1737360"/>
-            <a:ext cx="2286000" cy="1097280"/>
-          </a:xfrm>
-          <a:prstGeom prst="rect">
-            <a:avLst/>
-          </a:prstGeom>
-          <a:noFill/>
-          <a:ln/>
-        </p:spPr>
-        <p:txBody>
-          <a:bodyPr wrap="square" rtlCol="0" anchor="t"/>
-          <a:lstStyle/>
-          <a:p>
-            <a:pPr indent="0" marL="0">
-              <a:buNone/>
-            </a:pPr>
-            <a:r>
-              <a:rPr lang="en-US" sz="1100" dirty="0">
-                <a:solidFill>
-                  <a:srgbClr val="3D3A36"/>
-                </a:solidFill>
-                <a:latin typeface="Calibri" pitchFamily="34" charset="0"/>
-                <a:ea typeface="Calibri" pitchFamily="34" charset="-122"/>
-                <a:cs typeface="Calibri" pitchFamily="34" charset="-120"/>
-              </a:rPr>
-              <a:t>Actions that aid survival. Migration (birds fly south for winter), hibernation (bears sleep through winter), nocturnal activity (owls hunt at night).</a:t>
-            </a:r>
-            <a:endParaRPr lang="en-US" sz="1100" dirty="0"/>
-          </a:p>
-        </p:txBody>
-      </p:sp>
-      <p:sp>
-        <p:nvSpPr>
-          <p:cNvPr id="13" name="Shape 11"/>
-          <p:cNvSpPr/>
-          <p:nvPr/>
-        </p:nvSpPr>
-        <p:spPr>
-          <a:xfrm>
-            <a:off x="6126480" y="1188720"/>
-            <a:ext cx="2560320" cy="1828800"/>
-          </a:xfrm>
-          <a:prstGeom prst="rect">
-            <a:avLst/>
-          </a:prstGeom>
-          <a:solidFill>
-            <a:srgbClr val="FFFFFF"/>
-          </a:solidFill>
-          <a:ln w="12700">
-            <a:solidFill>
-              <a:srgbClr val="E5E2DC"/>
-            </a:solidFill>
-            <a:prstDash val="solid"/>
-          </a:ln>
-          <a:effectLst>
-            <a:outerShdw sx="100000" sy="100000" kx="0" ky="0" algn="bl" rotWithShape="0" blurRad="50800" dist="25400" dir="8100000">
-              <a:srgbClr val="000000">
-                <a:alpha val="10000"/>
-              </a:srgbClr>
-            </a:outerShdw>
-          </a:effectLst>
-        </p:spPr>
-      </p:sp>
-      <p:sp>
-        <p:nvSpPr>
-          <p:cNvPr id="14" name="Shape 12"/>
-          <p:cNvSpPr/>
-          <p:nvPr/>
-        </p:nvSpPr>
-        <p:spPr>
-          <a:xfrm>
-            <a:off x="6126480" y="1188720"/>
-            <a:ext cx="2560320" cy="54864"/>
-          </a:xfrm>
-          <a:prstGeom prst="rect">
-            <a:avLst/>
-          </a:prstGeom>
-          <a:solidFill>
-            <a:srgbClr val="2A9D8F"/>
-          </a:solidFill>
-          <a:ln/>
-        </p:spPr>
-      </p:sp>
-      <p:sp>
-        <p:nvSpPr>
-          <p:cNvPr id="15" name="Text 13"/>
-          <p:cNvSpPr/>
-          <p:nvPr/>
-        </p:nvSpPr>
-        <p:spPr>
-          <a:xfrm>
-            <a:off x="6263640" y="1325880"/>
-            <a:ext cx="2286000" cy="365760"/>
-          </a:xfrm>
-          <a:prstGeom prst="rect">
-            <a:avLst/>
-          </a:prstGeom>
-          <a:noFill/>
-          <a:ln/>
-        </p:spPr>
-        <p:txBody>
-          <a:bodyPr wrap="square" rtlCol="0" anchor="ctr"/>
-          <a:lstStyle/>
-          <a:p>
-            <a:pPr indent="0" marL="0">
-              <a:buNone/>
-            </a:pPr>
-            <a:r>
-              <a:rPr lang="en-US" sz="1400" b="1" dirty="0">
-                <a:solidFill>
-                  <a:srgbClr val="1B2A4A"/>
-                </a:solidFill>
-                <a:latin typeface="Calibri" pitchFamily="34" charset="0"/>
-                <a:ea typeface="Calibri" pitchFamily="34" charset="-122"/>
-                <a:cs typeface="Calibri" pitchFamily="34" charset="-120"/>
-              </a:rPr>
-              <a:t>Functional</a:t>
-            </a:r>
-            <a:endParaRPr lang="en-US" sz="1400" dirty="0"/>
-          </a:p>
-        </p:txBody>
-      </p:sp>
-      <p:sp>
-        <p:nvSpPr>
-          <p:cNvPr id="16" name="Text 14"/>
-          <p:cNvSpPr/>
-          <p:nvPr/>
-        </p:nvSpPr>
-        <p:spPr>
-          <a:xfrm>
-            <a:off x="6263640" y="1737360"/>
-            <a:ext cx="2286000" cy="1097280"/>
-          </a:xfrm>
-          <a:prstGeom prst="rect">
-            <a:avLst/>
-          </a:prstGeom>
-          <a:noFill/>
-          <a:ln/>
-        </p:spPr>
-        <p:txBody>
-          <a:bodyPr wrap="square" rtlCol="0" anchor="t"/>
-          <a:lstStyle/>
-          <a:p>
-            <a:pPr indent="0" marL="0">
-              <a:buNone/>
-            </a:pPr>
-            <a:r>
-              <a:rPr lang="en-US" sz="1100" dirty="0">
-                <a:solidFill>
-                  <a:srgbClr val="3D3A36"/>
-                </a:solidFill>
-                <a:latin typeface="Calibri" pitchFamily="34" charset="0"/>
-                <a:ea typeface="Calibri" pitchFamily="34" charset="-122"/>
-                <a:cs typeface="Calibri" pitchFamily="34" charset="-120"/>
-              </a:rPr>
-              <a:t>Internal body processes. Desert rats produce very concentrated urine to save water. Arctic fish have antifreeze proteins in blood. Camels store fat in humps.</a:t>
-            </a:r>
-            <a:endParaRPr lang="en-US" sz="1100" dirty="0"/>
+              <a:t>Adaptations develop over thousands of generations through natural selection.</a:t>
+            </a:r>
+            <a:endParaRPr lang="en-US" sz="1300" dirty="0"/>
           </a:p>
         </p:txBody>
       </p:sp>
@@ -2175,7 +2399,27 @@
         <p:spPr>
           <a:xfrm>
             <a:off x="0" y="0"/>
-            <a:ext cx="9144000" cy="54864"/>
+            <a:ext cx="9144000" cy="822960"/>
+          </a:xfrm>
+          <a:prstGeom prst="rect">
+            <a:avLst/>
+          </a:prstGeom>
+          <a:solidFill>
+            <a:srgbClr val="FFFFFF"/>
+          </a:solidFill>
+          <a:ln/>
+        </p:spPr>
+      </p:sp>
+      <p:sp>
+        <p:nvSpPr>
+          <p:cNvPr id="3" name="Shape 1"/>
+          <p:cNvSpPr/>
+          <p:nvPr/>
+        </p:nvSpPr>
+        <p:spPr>
+          <a:xfrm>
+            <a:off x="0" y="795528"/>
+            <a:ext cx="9144000" cy="27432"/>
           </a:xfrm>
           <a:prstGeom prst="rect">
             <a:avLst/>
@@ -2188,14 +2432,14 @@
       </p:sp>
       <p:sp>
         <p:nvSpPr>
-          <p:cNvPr id="3" name="Text 1"/>
-          <p:cNvSpPr/>
-          <p:nvPr/>
-        </p:nvSpPr>
-        <p:spPr>
-          <a:xfrm>
-            <a:off x="7772400" y="4709160"/>
-            <a:ext cx="1097280" cy="320040"/>
+          <p:cNvPr id="4" name="Text 2"/>
+          <p:cNvSpPr/>
+          <p:nvPr/>
+        </p:nvSpPr>
+        <p:spPr>
+          <a:xfrm>
+            <a:off x="640080" y="91440"/>
+            <a:ext cx="7863840" cy="640080"/>
           </a:xfrm>
           <a:prstGeom prst="rect">
             <a:avLst/>
@@ -2204,53 +2448,14 @@
           <a:ln/>
         </p:spPr>
         <p:txBody>
-          <a:bodyPr wrap="square" rtlCol="0" anchor="ctr"/>
-          <a:lstStyle/>
-          <a:p>
-            <a:pPr algn="r" indent="0" marL="0">
-              <a:buNone/>
-            </a:pPr>
-            <a:r>
-              <a:rPr lang="en-US" sz="900" dirty="0">
-                <a:solidFill>
-                  <a:srgbClr val="6B6660"/>
-                </a:solidFill>
-                <a:latin typeface="Calibri" pitchFamily="34" charset="0"/>
-                <a:ea typeface="Calibri" pitchFamily="34" charset="-122"/>
-                <a:cs typeface="Calibri" pitchFamily="34" charset="-120"/>
-              </a:rPr>
-              <a:t>4 / 5</a:t>
-            </a:r>
-            <a:endParaRPr lang="en-US" sz="900" dirty="0"/>
-          </a:p>
-        </p:txBody>
-      </p:sp>
-      <p:sp>
-        <p:nvSpPr>
-          <p:cNvPr id="4" name="Text 2"/>
-          <p:cNvSpPr/>
-          <p:nvPr/>
-        </p:nvSpPr>
-        <p:spPr>
-          <a:xfrm>
-            <a:off x="457200" y="274320"/>
-            <a:ext cx="8229600" cy="640080"/>
-          </a:xfrm>
-          <a:prstGeom prst="rect">
-            <a:avLst/>
-          </a:prstGeom>
-          <a:noFill/>
-          <a:ln/>
-        </p:spPr>
-        <p:txBody>
-          <a:bodyPr wrap="square" rtlCol="0" anchor="ctr"/>
+          <a:bodyPr wrap="square" lIns="0" tIns="0" rIns="0" bIns="0" rtlCol="0" anchor="ctr"/>
           <a:lstStyle/>
           <a:p>
             <a:pPr indent="0" marL="0">
               <a:buNone/>
             </a:pPr>
             <a:r>
-              <a:rPr lang="en-US" sz="2600" b="1" dirty="0">
+              <a:rPr lang="en-US" sz="2200" b="1" dirty="0">
                 <a:solidFill>
                   <a:srgbClr val="1B2A4A"/>
                 </a:solidFill>
@@ -2258,22 +2463,69 @@
                 <a:ea typeface="Georgia" pitchFamily="34" charset="-122"/>
                 <a:cs typeface="Georgia" pitchFamily="34" charset="-120"/>
               </a:rPr>
-              <a:t>Desert Adaptations</a:t>
-            </a:r>
-            <a:endParaRPr lang="en-US" sz="2600" dirty="0"/>
-          </a:p>
-        </p:txBody>
-      </p:sp>
-      <p:sp>
-        <p:nvSpPr>
-          <p:cNvPr id="5" name="Text 3"/>
-          <p:cNvSpPr/>
-          <p:nvPr/>
-        </p:nvSpPr>
-        <p:spPr>
-          <a:xfrm>
-            <a:off x="457200" y="1188720"/>
-            <a:ext cx="3840480" cy="3474720"/>
+              <a:t>Adaptations in Our Students' Worlds</a:t>
+            </a:r>
+            <a:endParaRPr lang="en-US" sz="2200" dirty="0"/>
+          </a:p>
+        </p:txBody>
+      </p:sp>
+      <p:sp>
+        <p:nvSpPr>
+          <p:cNvPr id="5" name="Shape 3"/>
+          <p:cNvSpPr/>
+          <p:nvPr/>
+        </p:nvSpPr>
+        <p:spPr>
+          <a:xfrm>
+            <a:off x="457200" y="1005840"/>
+            <a:ext cx="3931920" cy="3657600"/>
+          </a:xfrm>
+          <a:prstGeom prst="rect">
+            <a:avLst/>
+          </a:prstGeom>
+          <a:solidFill>
+            <a:srgbClr val="FFFFFF"/>
+          </a:solidFill>
+          <a:ln/>
+          <a:effectLst>
+            <a:outerShdw sx="100000" sy="100000" kx="0" ky="0" algn="bl" rotWithShape="0" blurRad="76200" dist="25400" dir="8100000">
+              <a:srgbClr val="000000">
+                <a:alpha val="12000"/>
+              </a:srgbClr>
+            </a:outerShdw>
+          </a:effectLst>
+        </p:spPr>
+      </p:sp>
+      <p:sp>
+        <p:nvSpPr>
+          <p:cNvPr id="6" name="Shape 4"/>
+          <p:cNvSpPr/>
+          <p:nvPr/>
+        </p:nvSpPr>
+        <p:spPr>
+          <a:xfrm>
+            <a:off x="457200" y="1005840"/>
+            <a:ext cx="3931920" cy="64008"/>
+          </a:xfrm>
+          <a:prstGeom prst="rect">
+            <a:avLst/>
+          </a:prstGeom>
+          <a:solidFill>
+            <a:srgbClr val="2A9D8F"/>
+          </a:solidFill>
+          <a:ln/>
+        </p:spPr>
+      </p:sp>
+      <p:sp>
+        <p:nvSpPr>
+          <p:cNvPr id="7" name="Text 5"/>
+          <p:cNvSpPr/>
+          <p:nvPr/>
+        </p:nvSpPr>
+        <p:spPr>
+          <a:xfrm>
+            <a:off x="640080" y="1188720"/>
+            <a:ext cx="3566160" cy="457200"/>
           </a:xfrm>
           <a:prstGeom prst="rect">
             <a:avLst/>
@@ -2282,7 +2534,46 @@
           <a:ln/>
         </p:spPr>
         <p:txBody>
-          <a:bodyPr wrap="square" rtlCol="0" anchor="t"/>
+          <a:bodyPr wrap="square" rtlCol="0" anchor="ctr"/>
+          <a:lstStyle/>
+          <a:p>
+            <a:pPr indent="0" marL="0">
+              <a:buNone/>
+            </a:pPr>
+            <a:r>
+              <a:rPr lang="en-US" sz="1600" b="1" dirty="0">
+                <a:solidFill>
+                  <a:srgbClr val="2A9D8F"/>
+                </a:solidFill>
+                <a:latin typeface="Calibri" pitchFamily="34" charset="0"/>
+                <a:ea typeface="Calibri" pitchFamily="34" charset="-122"/>
+                <a:cs typeface="Calibri" pitchFamily="34" charset="-120"/>
+              </a:rPr>
+              <a:t>Asian Adaptations</a:t>
+            </a:r>
+            <a:endParaRPr lang="en-US" sz="1600" dirty="0"/>
+          </a:p>
+        </p:txBody>
+      </p:sp>
+      <p:sp>
+        <p:nvSpPr>
+          <p:cNvPr id="8" name="Text 6"/>
+          <p:cNvSpPr/>
+          <p:nvPr/>
+        </p:nvSpPr>
+        <p:spPr>
+          <a:xfrm>
+            <a:off x="640080" y="1691640"/>
+            <a:ext cx="3566160" cy="2743200"/>
+          </a:xfrm>
+          <a:prstGeom prst="rect">
+            <a:avLst/>
+          </a:prstGeom>
+          <a:noFill/>
+          <a:ln/>
+        </p:spPr>
+        <p:txBody>
+          <a:bodyPr wrap="square" rtlCol="0" anchor="ctr"/>
           <a:lstStyle/>
           <a:p>
             <a:pPr marL="342900" indent="-342900">
@@ -2301,7 +2592,7 @@
                 <a:ea typeface="Calibri" pitchFamily="34" charset="-122"/>
                 <a:cs typeface="Calibri" pitchFamily="34" charset="-120"/>
               </a:rPr>
-              <a:t>Cactus: thick stem stores water, spines reduce water loss, shallow wide roots</a:t>
+              <a:t>Giant panda: 'pseudo-thumb' for gripping bamboo.</a:t>
             </a:r>
             <a:endParaRPr lang="en-US" sz="1400" dirty="0"/>
           </a:p>
@@ -2322,7 +2613,7 @@
                 <a:ea typeface="Calibri" pitchFamily="34" charset="-122"/>
                 <a:cs typeface="Calibri" pitchFamily="34" charset="-120"/>
               </a:rPr>
-              <a:t>Camel: fat stored in hump (not water!), thick eyelashes, wide feet for sand</a:t>
+              <a:t>Korean water deer: no antlers, but long fangs instead.</a:t>
             </a:r>
             <a:endParaRPr lang="en-US" sz="1400" dirty="0"/>
           </a:p>
@@ -2343,7 +2634,7 @@
                 <a:ea typeface="Calibri" pitchFamily="34" charset="-122"/>
                 <a:cs typeface="Calibri" pitchFamily="34" charset="-120"/>
               </a:rPr>
-              <a:t>Fennec fox: huge ears radiate heat, nocturnal, pale fur reflects sunlight</a:t>
+              <a:t>Chinese alligator: smaller body for Yangtze wetlands.</a:t>
             </a:r>
             <a:endParaRPr lang="en-US" sz="1400" dirty="0"/>
           </a:p>
@@ -2364,7 +2655,7 @@
                 <a:ea typeface="Calibri" pitchFamily="34" charset="-122"/>
                 <a:cs typeface="Calibri" pitchFamily="34" charset="-120"/>
               </a:rPr>
-              <a:t>Kangaroo rat: gets water from food, concentrated urine, burrows underground by day</a:t>
+              <a:t>Red-crowned crane: long legs for wading in Korean marshes.</a:t>
             </a:r>
             <a:endParaRPr lang="en-US" sz="1400" dirty="0"/>
           </a:p>
@@ -2372,14 +2663,14 @@
       </p:sp>
       <p:sp>
         <p:nvSpPr>
-          <p:cNvPr id="6" name="Shape 4"/>
-          <p:cNvSpPr/>
-          <p:nvPr/>
-        </p:nvSpPr>
-        <p:spPr>
-          <a:xfrm>
-            <a:off x="4846320" y="1188720"/>
-            <a:ext cx="3840480" cy="3474720"/>
+          <p:cNvPr id="9" name="Shape 7"/>
+          <p:cNvSpPr/>
+          <p:nvPr/>
+        </p:nvSpPr>
+        <p:spPr>
+          <a:xfrm>
+            <a:off x="4754880" y="1005840"/>
+            <a:ext cx="3931920" cy="3657600"/>
           </a:xfrm>
           <a:prstGeom prst="rect">
             <a:avLst/>
@@ -2387,16 +2678,11 @@
           <a:solidFill>
             <a:srgbClr val="FFFFFF"/>
           </a:solidFill>
-          <a:ln w="12700">
-            <a:solidFill>
-              <a:srgbClr val="E5E2DC"/>
-            </a:solidFill>
-            <a:prstDash val="solid"/>
-          </a:ln>
+          <a:ln/>
           <a:effectLst>
-            <a:outerShdw sx="100000" sy="100000" kx="0" ky="0" algn="bl" rotWithShape="0" blurRad="50800" dist="25400" dir="8100000">
+            <a:outerShdw sx="100000" sy="100000" kx="0" ky="0" algn="bl" rotWithShape="0" blurRad="76200" dist="25400" dir="8100000">
               <a:srgbClr val="000000">
-                <a:alpha val="10000"/>
+                <a:alpha val="12000"/>
               </a:srgbClr>
             </a:outerShdw>
           </a:effectLst>
@@ -2404,34 +2690,34 @@
       </p:sp>
       <p:sp>
         <p:nvSpPr>
-          <p:cNvPr id="7" name="Shape 5"/>
-          <p:cNvSpPr/>
-          <p:nvPr/>
-        </p:nvSpPr>
-        <p:spPr>
-          <a:xfrm>
-            <a:off x="4846320" y="1188720"/>
-            <a:ext cx="3840480" cy="54864"/>
-          </a:xfrm>
-          <a:prstGeom prst="rect">
-            <a:avLst/>
-          </a:prstGeom>
-          <a:solidFill>
-            <a:srgbClr val="2A9D8F"/>
-          </a:solidFill>
-          <a:ln/>
-        </p:spPr>
-      </p:sp>
-      <p:sp>
-        <p:nvSpPr>
-          <p:cNvPr id="8" name="Text 6"/>
-          <p:cNvSpPr/>
-          <p:nvPr/>
-        </p:nvSpPr>
-        <p:spPr>
-          <a:xfrm>
-            <a:off x="5120640" y="1371600"/>
-            <a:ext cx="3291840" cy="3108960"/>
+          <p:cNvPr id="10" name="Shape 8"/>
+          <p:cNvSpPr/>
+          <p:nvPr/>
+        </p:nvSpPr>
+        <p:spPr>
+          <a:xfrm>
+            <a:off x="4754880" y="1005840"/>
+            <a:ext cx="3931920" cy="64008"/>
+          </a:xfrm>
+          <a:prstGeom prst="rect">
+            <a:avLst/>
+          </a:prstGeom>
+          <a:solidFill>
+            <a:srgbClr val="E9C46A"/>
+          </a:solidFill>
+          <a:ln/>
+        </p:spPr>
+      </p:sp>
+      <p:sp>
+        <p:nvSpPr>
+          <p:cNvPr id="11" name="Text 9"/>
+          <p:cNvSpPr/>
+          <p:nvPr/>
+        </p:nvSpPr>
+        <p:spPr>
+          <a:xfrm>
+            <a:off x="4937760" y="1188720"/>
+            <a:ext cx="3566160" cy="457200"/>
           </a:xfrm>
           <a:prstGeom prst="rect">
             <a:avLst/>
@@ -2440,46 +2726,99 @@
           <a:ln/>
         </p:spPr>
         <p:txBody>
-          <a:bodyPr wrap="square" rtlCol="0" anchor="t"/>
+          <a:bodyPr wrap="square" rtlCol="0" anchor="ctr"/>
           <a:lstStyle/>
           <a:p>
             <a:pPr indent="0" marL="0">
+              <a:buNone/>
+            </a:pPr>
+            <a:r>
+              <a:rPr lang="en-US" sz="1600" b="1" dirty="0">
+                <a:solidFill>
+                  <a:srgbClr val="E9C46A"/>
+                </a:solidFill>
+                <a:latin typeface="Calibri" pitchFamily="34" charset="0"/>
+                <a:ea typeface="Calibri" pitchFamily="34" charset="-122"/>
+                <a:cs typeface="Calibri" pitchFamily="34" charset="-120"/>
+              </a:rPr>
+              <a:t>European Adaptations</a:t>
+            </a:r>
+            <a:endParaRPr lang="en-US" sz="1600" dirty="0"/>
+          </a:p>
+        </p:txBody>
+      </p:sp>
+      <p:sp>
+        <p:nvSpPr>
+          <p:cNvPr id="12" name="Text 10"/>
+          <p:cNvSpPr/>
+          <p:nvPr/>
+        </p:nvSpPr>
+        <p:spPr>
+          <a:xfrm>
+            <a:off x="4937760" y="1691640"/>
+            <a:ext cx="3566160" cy="2743200"/>
+          </a:xfrm>
+          <a:prstGeom prst="rect">
+            <a:avLst/>
+          </a:prstGeom>
+          <a:noFill/>
+          <a:ln/>
+        </p:spPr>
+        <p:txBody>
+          <a:bodyPr wrap="square" rtlCol="0" anchor="ctr"/>
+          <a:lstStyle/>
+          <a:p>
+            <a:pPr marL="342900" indent="-342900">
               <a:spcAft>
-                <a:spcPts val="400"/>
+                <a:spcPts val="600"/>
               </a:spcAft>
-              <a:buNone/>
-            </a:pPr>
-            <a:r>
-              <a:rPr lang="en-US" sz="1600" b="1" dirty="0">
-                <a:solidFill>
-                  <a:srgbClr val="1B2A4A"/>
-                </a:solidFill>
-                <a:latin typeface="Calibri" pitchFamily="34" charset="0"/>
-                <a:ea typeface="Calibri" pitchFamily="34" charset="-122"/>
-                <a:cs typeface="Calibri" pitchFamily="34" charset="-120"/>
-              </a:rPr>
-              <a:t>Arctic Adaptations</a:t>
-            </a:r>
-            <a:endParaRPr lang="en-US" sz="1600" dirty="0"/>
-          </a:p>
-          <a:p>
-            <a:pPr indent="0" marL="0">
+              <a:buSzPct val="100000"/>
+              <a:buChar char="•"/>
+            </a:pPr>
+            <a:r>
+              <a:rPr lang="en-US" sz="1400" dirty="0">
+                <a:solidFill>
+                  <a:srgbClr val="3D3A36"/>
+                </a:solidFill>
+                <a:latin typeface="Calibri" pitchFamily="34" charset="0"/>
+                <a:ea typeface="Calibri" pitchFamily="34" charset="-122"/>
+                <a:cs typeface="Calibri" pitchFamily="34" charset="-120"/>
+              </a:rPr>
+              <a:t>European badger: thick fur for cold German winters.</a:t>
+            </a:r>
+            <a:endParaRPr lang="en-US" sz="1400" dirty="0"/>
+          </a:p>
+          <a:p>
+            <a:pPr marL="342900" indent="-342900">
               <a:spcAft>
-                <a:spcPts val="400"/>
+                <a:spcPts val="600"/>
               </a:spcAft>
-              <a:buNone/>
-            </a:pPr>
-            <a:endParaRPr lang="en-US" sz="1600" dirty="0"/>
-          </a:p>
-          <a:p>
-            <a:pPr indent="0" marL="0">
+              <a:buSzPct val="100000"/>
+              <a:buChar char="•"/>
+            </a:pPr>
+            <a:r>
+              <a:rPr lang="en-US" sz="1400" dirty="0">
+                <a:solidFill>
+                  <a:srgbClr val="3D3A36"/>
+                </a:solidFill>
+                <a:latin typeface="Calibri" pitchFamily="34" charset="0"/>
+                <a:ea typeface="Calibri" pitchFamily="34" charset="-122"/>
+                <a:cs typeface="Calibri" pitchFamily="34" charset="-120"/>
+              </a:rPr>
+              <a:t>Alpine ibex: hooves shaped for steep mountain rocks.</a:t>
+            </a:r>
+            <a:endParaRPr lang="en-US" sz="1400" dirty="0"/>
+          </a:p>
+          <a:p>
+            <a:pPr marL="342900" indent="-342900">
               <a:spcAft>
-                <a:spcPts val="400"/>
+                <a:spcPts val="600"/>
               </a:spcAft>
-              <a:buNone/>
-            </a:pPr>
-            <a:r>
-              <a:rPr lang="en-US" sz="1300" dirty="0">
+              <a:buSzPct val="100000"/>
+              <a:buChar char="•"/>
+            </a:pPr>
+            <a:r>
+              <a:rPr lang="en-US" sz="1400" dirty="0">
                 <a:solidFill>
                   <a:srgbClr val="3D3A36"/>
                 </a:solidFill>
@@ -2487,19 +2826,20 @@
                 <a:ea typeface="Calibri" pitchFamily="34" charset="-122"/>
                 <a:cs typeface="Calibri" pitchFamily="34" charset="-120"/>
               </a:rPr>
-              <a:t>Polar bear: thick blubber, white fur (camouflage), large paws spread weight on ice</a:t>
-            </a:r>
-            <a:endParaRPr lang="en-US" sz="1600" dirty="0"/>
-          </a:p>
-          <a:p>
-            <a:pPr indent="0" marL="0">
+              <a:t>European mole: shovel-like paws for digging.</a:t>
+            </a:r>
+            <a:endParaRPr lang="en-US" sz="1400" dirty="0"/>
+          </a:p>
+          <a:p>
+            <a:pPr marL="342900" indent="-342900">
               <a:spcAft>
-                <a:spcPts val="400"/>
+                <a:spcPts val="600"/>
               </a:spcAft>
-              <a:buNone/>
-            </a:pPr>
-            <a:r>
-              <a:rPr lang="en-US" sz="1300" dirty="0">
+              <a:buSzPct val="100000"/>
+              <a:buChar char="•"/>
+            </a:pPr>
+            <a:r>
+              <a:rPr lang="en-US" sz="1400" dirty="0">
                 <a:solidFill>
                   <a:srgbClr val="3D3A36"/>
                 </a:solidFill>
@@ -2507,49 +2847,9 @@
                 <a:ea typeface="Calibri" pitchFamily="34" charset="-122"/>
                 <a:cs typeface="Calibri" pitchFamily="34" charset="-120"/>
               </a:rPr>
-              <a:t>Arctic fox: thick fur changes colour (white winter, brown summer)</a:t>
-            </a:r>
-            <a:endParaRPr lang="en-US" sz="1600" dirty="0"/>
-          </a:p>
-          <a:p>
-            <a:pPr indent="0" marL="0">
-              <a:spcAft>
-                <a:spcPts val="400"/>
-              </a:spcAft>
-              <a:buNone/>
-            </a:pPr>
-            <a:r>
-              <a:rPr lang="en-US" sz="1300" dirty="0">
-                <a:solidFill>
-                  <a:srgbClr val="3D3A36"/>
-                </a:solidFill>
-                <a:latin typeface="Calibri" pitchFamily="34" charset="0"/>
-                <a:ea typeface="Calibri" pitchFamily="34" charset="-122"/>
-                <a:cs typeface="Calibri" pitchFamily="34" charset="-120"/>
-              </a:rPr>
-              <a:t>Penguin: huddle together for warmth, streamlined for swimming, countercurrent blood flow</a:t>
-            </a:r>
-            <a:endParaRPr lang="en-US" sz="1600" dirty="0"/>
-          </a:p>
-          <a:p>
-            <a:pPr indent="0" marL="0">
-              <a:spcAft>
-                <a:spcPts val="400"/>
-              </a:spcAft>
-              <a:buNone/>
-            </a:pPr>
-            <a:r>
-              <a:rPr lang="en-US" sz="1300" dirty="0">
-                <a:solidFill>
-                  <a:srgbClr val="3D3A36"/>
-                </a:solidFill>
-                <a:latin typeface="Calibri" pitchFamily="34" charset="0"/>
-                <a:ea typeface="Calibri" pitchFamily="34" charset="-122"/>
-                <a:cs typeface="Calibri" pitchFamily="34" charset="-120"/>
-              </a:rPr>
-              <a:t>Walrus: thick blubber, tusks for pulling onto ice, whiskers for finding food in murky water</a:t>
-            </a:r>
-            <a:endParaRPr lang="en-US" sz="1600" dirty="0"/>
+              <a:t>Black Forest woodpecker: reinforced skull for pecking.</a:t>
+            </a:r>
+            <a:endParaRPr lang="en-US" sz="1400" dirty="0"/>
           </a:p>
         </p:txBody>
       </p:sp>
@@ -2567,7 +2867,7 @@
     <p:bg>
       <p:bgPr>
         <a:solidFill>
-          <a:srgbClr val="1B2A4A"/>
+          <a:srgbClr val="FAF8F5"/>
         </a:solidFill>
       </p:bgPr>
     </p:bg>
@@ -2594,27 +2894,47 @@
         <p:spPr>
           <a:xfrm>
             <a:off x="0" y="0"/>
-            <a:ext cx="109728" cy="5143500"/>
-          </a:xfrm>
-          <a:prstGeom prst="rect">
-            <a:avLst/>
-          </a:prstGeom>
-          <a:solidFill>
-            <a:srgbClr val="E9C46A"/>
-          </a:solidFill>
-          <a:ln/>
-        </p:spPr>
-      </p:sp>
-      <p:sp>
-        <p:nvSpPr>
-          <p:cNvPr id="3" name="Text 1"/>
-          <p:cNvSpPr/>
-          <p:nvPr/>
-        </p:nvSpPr>
-        <p:spPr>
-          <a:xfrm>
-            <a:off x="731520" y="457200"/>
-            <a:ext cx="7772400" cy="731520"/>
+            <a:ext cx="9144000" cy="822960"/>
+          </a:xfrm>
+          <a:prstGeom prst="rect">
+            <a:avLst/>
+          </a:prstGeom>
+          <a:solidFill>
+            <a:srgbClr val="FFFFFF"/>
+          </a:solidFill>
+          <a:ln/>
+        </p:spPr>
+      </p:sp>
+      <p:sp>
+        <p:nvSpPr>
+          <p:cNvPr id="3" name="Shape 1"/>
+          <p:cNvSpPr/>
+          <p:nvPr/>
+        </p:nvSpPr>
+        <p:spPr>
+          <a:xfrm>
+            <a:off x="0" y="795528"/>
+            <a:ext cx="9144000" cy="27432"/>
+          </a:xfrm>
+          <a:prstGeom prst="rect">
+            <a:avLst/>
+          </a:prstGeom>
+          <a:solidFill>
+            <a:srgbClr val="2A9D8F"/>
+          </a:solidFill>
+          <a:ln/>
+        </p:spPr>
+      </p:sp>
+      <p:sp>
+        <p:nvSpPr>
+          <p:cNvPr id="4" name="Text 2"/>
+          <p:cNvSpPr/>
+          <p:nvPr/>
+        </p:nvSpPr>
+        <p:spPr>
+          <a:xfrm>
+            <a:off x="640080" y="91440"/>
+            <a:ext cx="7863840" cy="640080"/>
           </a:xfrm>
           <a:prstGeom prst="rect">
             <a:avLst/>
@@ -2623,37 +2943,37 @@
           <a:ln/>
         </p:spPr>
         <p:txBody>
-          <a:bodyPr wrap="square" rtlCol="0" anchor="ctr"/>
+          <a:bodyPr wrap="square" lIns="0" tIns="0" rIns="0" bIns="0" rtlCol="0" anchor="ctr"/>
           <a:lstStyle/>
           <a:p>
             <a:pPr indent="0" marL="0">
               <a:buNone/>
             </a:pPr>
             <a:r>
-              <a:rPr lang="en-US" sz="3200" b="1" dirty="0">
-                <a:solidFill>
-                  <a:srgbClr val="FFFFFF"/>
+              <a:rPr lang="en-US" sz="2200" b="1" dirty="0">
+                <a:solidFill>
+                  <a:srgbClr val="1B2A4A"/>
                 </a:solidFill>
                 <a:latin typeface="Georgia" pitchFamily="34" charset="0"/>
                 <a:ea typeface="Georgia" pitchFamily="34" charset="-122"/>
                 <a:cs typeface="Georgia" pitchFamily="34" charset="-120"/>
               </a:rPr>
-              <a:t>Key Takeaways</a:t>
-            </a:r>
-            <a:endParaRPr lang="en-US" sz="3200" dirty="0"/>
-          </a:p>
-        </p:txBody>
-      </p:sp>
-      <p:sp>
-        <p:nvSpPr>
-          <p:cNvPr id="4" name="Text 2"/>
-          <p:cNvSpPr/>
-          <p:nvPr/>
-        </p:nvSpPr>
-        <p:spPr>
-          <a:xfrm>
-            <a:off x="731520" y="1463040"/>
-            <a:ext cx="7772400" cy="3200400"/>
+              <a:t>Adaptations to Extreme Environments</a:t>
+            </a:r>
+            <a:endParaRPr lang="en-US" sz="2200" dirty="0"/>
+          </a:p>
+        </p:txBody>
+      </p:sp>
+      <p:sp>
+        <p:nvSpPr>
+          <p:cNvPr id="5" name="Text 3"/>
+          <p:cNvSpPr/>
+          <p:nvPr/>
+        </p:nvSpPr>
+        <p:spPr>
+          <a:xfrm>
+            <a:off x="640080" y="1005840"/>
+            <a:ext cx="7863840" cy="2926080"/>
           </a:xfrm>
           <a:prstGeom prst="rect">
             <a:avLst/>
@@ -2662,125 +2982,500 @@
           <a:ln/>
         </p:spPr>
         <p:txBody>
-          <a:bodyPr wrap="square" rtlCol="0" anchor="t"/>
+          <a:bodyPr wrap="square" rtlCol="0" anchor="ctr"/>
           <a:lstStyle/>
           <a:p>
             <a:pPr marL="342900" indent="-342900">
               <a:spcAft>
-                <a:spcPts val="1000"/>
+                <a:spcPts val="800"/>
               </a:spcAft>
               <a:buSzPct val="100000"/>
               <a:buChar char="•"/>
             </a:pPr>
             <a:r>
-              <a:rPr lang="en-US" sz="1500" dirty="0">
-                <a:solidFill>
-                  <a:srgbClr val="CADCFC"/>
-                </a:solidFill>
-                <a:latin typeface="Calibri" pitchFamily="34" charset="0"/>
-                <a:ea typeface="Calibri" pitchFamily="34" charset="-122"/>
-                <a:cs typeface="Calibri" pitchFamily="34" charset="-120"/>
-              </a:rPr>
-              <a:t>Adaptation = feature that helps survival in a habitat</a:t>
-            </a:r>
-            <a:endParaRPr lang="en-US" sz="1500" dirty="0"/>
+              <a:rPr lang="en-US" sz="1600" dirty="0">
+                <a:solidFill>
+                  <a:srgbClr val="3D3A36"/>
+                </a:solidFill>
+                <a:latin typeface="Calibri" pitchFamily="34" charset="0"/>
+                <a:ea typeface="Calibri" pitchFamily="34" charset="-122"/>
+                <a:cs typeface="Calibri" pitchFamily="34" charset="-120"/>
+              </a:rPr>
+              <a:t>Arctic: thick blubber (whale), white fur (polar bear), antifreeze proteins (fish).</a:t>
+            </a:r>
+            <a:endParaRPr lang="en-US" sz="1600" dirty="0"/>
           </a:p>
           <a:p>
             <a:pPr marL="342900" indent="-342900">
               <a:spcAft>
-                <a:spcPts val="1000"/>
+                <a:spcPts val="800"/>
               </a:spcAft>
               <a:buSzPct val="100000"/>
               <a:buChar char="•"/>
             </a:pPr>
             <a:r>
-              <a:rPr lang="en-US" sz="1500" dirty="0">
-                <a:solidFill>
-                  <a:srgbClr val="CADCFC"/>
-                </a:solidFill>
-                <a:latin typeface="Calibri" pitchFamily="34" charset="0"/>
-                <a:ea typeface="Calibri" pitchFamily="34" charset="-122"/>
-                <a:cs typeface="Calibri" pitchFamily="34" charset="-120"/>
-              </a:rPr>
-              <a:t>Three types: structural (body), behavioural (actions), functional (internal processes)</a:t>
-            </a:r>
-            <a:endParaRPr lang="en-US" sz="1500" dirty="0"/>
+              <a:rPr lang="en-US" sz="1600" dirty="0">
+                <a:solidFill>
+                  <a:srgbClr val="3D3A36"/>
+                </a:solidFill>
+                <a:latin typeface="Calibri" pitchFamily="34" charset="0"/>
+                <a:ea typeface="Calibri" pitchFamily="34" charset="-122"/>
+                <a:cs typeface="Calibri" pitchFamily="34" charset="-120"/>
+              </a:rPr>
+              <a:t>Desert: water storage (camel), nocturnal behaviour, large ears for cooling (fennec fox).</a:t>
+            </a:r>
+            <a:endParaRPr lang="en-US" sz="1600" dirty="0"/>
           </a:p>
           <a:p>
             <a:pPr marL="342900" indent="-342900">
               <a:spcAft>
-                <a:spcPts val="1000"/>
+                <a:spcPts val="800"/>
               </a:spcAft>
               <a:buSzPct val="100000"/>
               <a:buChar char="•"/>
             </a:pPr>
             <a:r>
-              <a:rPr lang="en-US" sz="1500" dirty="0">
-                <a:solidFill>
-                  <a:srgbClr val="CADCFC"/>
-                </a:solidFill>
-                <a:latin typeface="Calibri" pitchFamily="34" charset="0"/>
-                <a:ea typeface="Calibri" pitchFamily="34" charset="-122"/>
-                <a:cs typeface="Calibri" pitchFamily="34" charset="-120"/>
-              </a:rPr>
-              <a:t>Adaptations develop over generations through natural selection</a:t>
-            </a:r>
-            <a:endParaRPr lang="en-US" sz="1500" dirty="0"/>
+              <a:rPr lang="en-US" sz="1600" dirty="0">
+                <a:solidFill>
+                  <a:srgbClr val="3D3A36"/>
+                </a:solidFill>
+                <a:latin typeface="Calibri" pitchFamily="34" charset="0"/>
+                <a:ea typeface="Calibri" pitchFamily="34" charset="-122"/>
+                <a:cs typeface="Calibri" pitchFamily="34" charset="-120"/>
+              </a:rPr>
+              <a:t>Deep ocean: bioluminescence, pressure-resistant bodies, no eyes (cave fish).</a:t>
+            </a:r>
+            <a:endParaRPr lang="en-US" sz="1600" dirty="0"/>
           </a:p>
           <a:p>
             <a:pPr marL="342900" indent="-342900">
               <a:spcAft>
-                <a:spcPts val="1000"/>
+                <a:spcPts val="800"/>
               </a:spcAft>
               <a:buSzPct val="100000"/>
               <a:buChar char="•"/>
             </a:pPr>
             <a:r>
-              <a:rPr lang="en-US" sz="1500" dirty="0">
-                <a:solidFill>
-                  <a:srgbClr val="CADCFC"/>
-                </a:solidFill>
-                <a:latin typeface="Calibri" pitchFamily="34" charset="0"/>
-                <a:ea typeface="Calibri" pitchFamily="34" charset="-122"/>
-                <a:cs typeface="Calibri" pitchFamily="34" charset="-120"/>
-              </a:rPr>
-              <a:t>Desert adaptations focus on water conservation and heat loss</a:t>
-            </a:r>
-            <a:endParaRPr lang="en-US" sz="1500" dirty="0"/>
-          </a:p>
+              <a:rPr lang="en-US" sz="1600" dirty="0">
+                <a:solidFill>
+                  <a:srgbClr val="3D3A36"/>
+                </a:solidFill>
+                <a:latin typeface="Calibri" pitchFamily="34" charset="0"/>
+                <a:ea typeface="Calibri" pitchFamily="34" charset="-122"/>
+                <a:cs typeface="Calibri" pitchFamily="34" charset="-120"/>
+              </a:rPr>
+              <a:t>Cities: urban foxes, pigeons, rats — adapted to live alongside humans.</a:t>
+            </a:r>
+            <a:endParaRPr lang="en-US" sz="1600" dirty="0"/>
+          </a:p>
+        </p:txBody>
+      </p:sp>
+      <p:sp>
+        <p:nvSpPr>
+          <p:cNvPr id="6" name="Shape 4"/>
+          <p:cNvSpPr/>
+          <p:nvPr/>
+        </p:nvSpPr>
+        <p:spPr>
+          <a:xfrm>
+            <a:off x="640080" y="4114800"/>
+            <a:ext cx="7863840" cy="731520"/>
+          </a:xfrm>
+          <a:prstGeom prst="rect">
+            <a:avLst/>
+          </a:prstGeom>
+          <a:solidFill>
+            <a:srgbClr val="E8F5F3"/>
+          </a:solidFill>
+          <a:ln/>
+          <a:effectLst>
+            <a:outerShdw sx="100000" sy="100000" kx="0" ky="0" algn="bl" rotWithShape="0" blurRad="76200" dist="25400" dir="8100000">
+              <a:srgbClr val="000000">
+                <a:alpha val="12000"/>
+              </a:srgbClr>
+            </a:outerShdw>
+          </a:effectLst>
+        </p:spPr>
+      </p:sp>
+      <p:sp>
+        <p:nvSpPr>
+          <p:cNvPr id="7" name="Shape 5"/>
+          <p:cNvSpPr/>
+          <p:nvPr/>
+        </p:nvSpPr>
+        <p:spPr>
+          <a:xfrm>
+            <a:off x="640080" y="4114800"/>
+            <a:ext cx="64008" cy="731520"/>
+          </a:xfrm>
+          <a:prstGeom prst="rect">
+            <a:avLst/>
+          </a:prstGeom>
+          <a:solidFill>
+            <a:srgbClr val="2A9D8F"/>
+          </a:solidFill>
+          <a:ln/>
+        </p:spPr>
+      </p:sp>
+      <p:sp>
+        <p:nvSpPr>
+          <p:cNvPr id="8" name="Text 6"/>
+          <p:cNvSpPr/>
+          <p:nvPr/>
+        </p:nvSpPr>
+        <p:spPr>
+          <a:xfrm>
+            <a:off x="914400" y="4160520"/>
+            <a:ext cx="7406640" cy="640080"/>
+          </a:xfrm>
+          <a:prstGeom prst="rect">
+            <a:avLst/>
+          </a:prstGeom>
+          <a:noFill/>
+          <a:ln/>
+        </p:spPr>
+        <p:txBody>
+          <a:bodyPr wrap="square" rtlCol="0" anchor="ctr"/>
+          <a:lstStyle/>
+          <a:p>
+            <a:pPr indent="0" marL="0">
+              <a:buNone/>
+            </a:pPr>
+            <a:r>
+              <a:rPr lang="en-US" sz="1300" i="1" dirty="0">
+                <a:solidFill>
+                  <a:srgbClr val="3D3A36"/>
+                </a:solidFill>
+                <a:latin typeface="Calibri" pitchFamily="34" charset="0"/>
+                <a:ea typeface="Calibri" pitchFamily="34" charset="-122"/>
+                <a:cs typeface="Calibri" pitchFamily="34" charset="-120"/>
+              </a:rPr>
+              <a:t>Nanjing's Xuanwu Lake birds have adapted to survive despite urban noise, light, and pollution.</a:t>
+            </a:r>
+            <a:endParaRPr lang="en-US" sz="1300" dirty="0"/>
+          </a:p>
+        </p:txBody>
+      </p:sp>
+    </p:spTree>
+  </p:cSld>
+  <p:clrMapOvr>
+    <a:masterClrMapping/>
+  </p:clrMapOvr>
+</p:sld>
+</file>
+
+<file path=ppt/slides/slide6.xml><?xml version="1.0" encoding="utf-8"?>
+<p:sld xmlns:a="http://schemas.openxmlformats.org/drawingml/2006/main" xmlns:r="http://schemas.openxmlformats.org/officeDocument/2006/relationships" xmlns:p="http://schemas.openxmlformats.org/presentationml/2006/main">
+  <p:cSld name="Slide 6">
+    <p:bg>
+      <p:bgPr>
+        <a:solidFill>
+          <a:srgbClr val="FAF8F5"/>
+        </a:solidFill>
+      </p:bgPr>
+    </p:bg>
+    <p:spTree>
+      <p:nvGrpSpPr>
+        <p:cNvPr id="1" name=""/>
+        <p:cNvGrpSpPr/>
+        <p:nvPr/>
+      </p:nvGrpSpPr>
+      <p:grpSpPr>
+        <a:xfrm>
+          <a:off x="0" y="0"/>
+          <a:ext cx="0" cy="0"/>
+          <a:chOff x="0" y="0"/>
+          <a:chExt cx="0" cy="0"/>
+        </a:xfrm>
+      </p:grpSpPr>
+      <p:sp>
+        <p:nvSpPr>
+          <p:cNvPr id="2" name="Shape 0"/>
+          <p:cNvSpPr/>
+          <p:nvPr/>
+        </p:nvSpPr>
+        <p:spPr>
+          <a:xfrm>
+            <a:off x="0" y="0"/>
+            <a:ext cx="9144000" cy="822960"/>
+          </a:xfrm>
+          <a:prstGeom prst="rect">
+            <a:avLst/>
+          </a:prstGeom>
+          <a:solidFill>
+            <a:srgbClr val="FFFFFF"/>
+          </a:solidFill>
+          <a:ln/>
+        </p:spPr>
+      </p:sp>
+      <p:sp>
+        <p:nvSpPr>
+          <p:cNvPr id="3" name="Shape 1"/>
+          <p:cNvSpPr/>
+          <p:nvPr/>
+        </p:nvSpPr>
+        <p:spPr>
+          <a:xfrm>
+            <a:off x="0" y="795528"/>
+            <a:ext cx="9144000" cy="27432"/>
+          </a:xfrm>
+          <a:prstGeom prst="rect">
+            <a:avLst/>
+          </a:prstGeom>
+          <a:solidFill>
+            <a:srgbClr val="2A9D8F"/>
+          </a:solidFill>
+          <a:ln/>
+        </p:spPr>
+      </p:sp>
+      <p:sp>
+        <p:nvSpPr>
+          <p:cNvPr id="4" name="Text 2"/>
+          <p:cNvSpPr/>
+          <p:nvPr/>
+        </p:nvSpPr>
+        <p:spPr>
+          <a:xfrm>
+            <a:off x="640080" y="91440"/>
+            <a:ext cx="7863840" cy="640080"/>
+          </a:xfrm>
+          <a:prstGeom prst="rect">
+            <a:avLst/>
+          </a:prstGeom>
+          <a:noFill/>
+          <a:ln/>
+        </p:spPr>
+        <p:txBody>
+          <a:bodyPr wrap="square" lIns="0" tIns="0" rIns="0" bIns="0" rtlCol="0" anchor="ctr"/>
+          <a:lstStyle/>
+          <a:p>
+            <a:pPr indent="0" marL="0">
+              <a:buNone/>
+            </a:pPr>
+            <a:r>
+              <a:rPr lang="en-US" sz="2200" b="1" dirty="0">
+                <a:solidFill>
+                  <a:srgbClr val="1B2A4A"/>
+                </a:solidFill>
+                <a:latin typeface="Georgia" pitchFamily="34" charset="0"/>
+                <a:ea typeface="Georgia" pitchFamily="34" charset="-122"/>
+                <a:cs typeface="Georgia" pitchFamily="34" charset="-120"/>
+              </a:rPr>
+              <a:t>Adaptation vs. Acclimatisation</a:t>
+            </a:r>
+            <a:endParaRPr lang="en-US" sz="2200" dirty="0"/>
+          </a:p>
+        </p:txBody>
+      </p:sp>
+      <p:sp>
+        <p:nvSpPr>
+          <p:cNvPr id="5" name="Text 3"/>
+          <p:cNvSpPr/>
+          <p:nvPr/>
+        </p:nvSpPr>
+        <p:spPr>
+          <a:xfrm>
+            <a:off x="640080" y="1005840"/>
+            <a:ext cx="7863840" cy="2926080"/>
+          </a:xfrm>
+          <a:prstGeom prst="rect">
+            <a:avLst/>
+          </a:prstGeom>
+          <a:noFill/>
+          <a:ln/>
+        </p:spPr>
+        <p:txBody>
+          <a:bodyPr wrap="square" rtlCol="0" anchor="ctr"/>
+          <a:lstStyle/>
           <a:p>
             <a:pPr marL="342900" indent="-342900">
               <a:spcAft>
-                <a:spcPts val="1000"/>
+                <a:spcPts val="800"/>
               </a:spcAft>
               <a:buSzPct val="100000"/>
               <a:buChar char="•"/>
             </a:pPr>
             <a:r>
-              <a:rPr lang="en-US" sz="1500" dirty="0">
-                <a:solidFill>
-                  <a:srgbClr val="CADCFC"/>
-                </a:solidFill>
-                <a:latin typeface="Calibri" pitchFamily="34" charset="0"/>
-                <a:ea typeface="Calibri" pitchFamily="34" charset="-122"/>
-                <a:cs typeface="Calibri" pitchFamily="34" charset="-120"/>
-              </a:rPr>
-              <a:t>Arctic adaptations focus on insulation and camouflage</a:t>
-            </a:r>
-            <a:endParaRPr lang="en-US" sz="1500" dirty="0"/>
-          </a:p>
-        </p:txBody>
-      </p:sp>
-      <p:sp>
-        <p:nvSpPr>
-          <p:cNvPr id="5" name="Text 3"/>
-          <p:cNvSpPr/>
-          <p:nvPr/>
-        </p:nvSpPr>
-        <p:spPr>
-          <a:xfrm>
-            <a:off x="731520" y="4572000"/>
-            <a:ext cx="7772400" cy="365760"/>
+              <a:rPr lang="en-US" sz="1600" dirty="0">
+                <a:solidFill>
+                  <a:srgbClr val="3D3A36"/>
+                </a:solidFill>
+                <a:latin typeface="Calibri" pitchFamily="34" charset="0"/>
+                <a:ea typeface="Calibri" pitchFamily="34" charset="-122"/>
+                <a:cs typeface="Calibri" pitchFamily="34" charset="-120"/>
+              </a:rPr>
+              <a:t>Adaptation: genetic change over many generations (evolution).</a:t>
+            </a:r>
+            <a:endParaRPr lang="en-US" sz="1600" dirty="0"/>
+          </a:p>
+          <a:p>
+            <a:pPr marL="342900" indent="-342900">
+              <a:spcAft>
+                <a:spcPts val="800"/>
+              </a:spcAft>
+              <a:buSzPct val="100000"/>
+              <a:buChar char="•"/>
+            </a:pPr>
+            <a:r>
+              <a:rPr lang="en-US" sz="1600" dirty="0">
+                <a:solidFill>
+                  <a:srgbClr val="3D3A36"/>
+                </a:solidFill>
+                <a:latin typeface="Calibri" pitchFamily="34" charset="0"/>
+                <a:ea typeface="Calibri" pitchFamily="34" charset="-122"/>
+                <a:cs typeface="Calibri" pitchFamily="34" charset="-120"/>
+              </a:rPr>
+              <a:t>Acclimatisation: short-term adjustment within one lifetime.</a:t>
+            </a:r>
+            <a:endParaRPr lang="en-US" sz="1600" dirty="0"/>
+          </a:p>
+          <a:p>
+            <a:pPr marL="342900" indent="-342900">
+              <a:spcAft>
+                <a:spcPts val="800"/>
+              </a:spcAft>
+              <a:buSzPct val="100000"/>
+              <a:buChar char="•"/>
+            </a:pPr>
+            <a:r>
+              <a:rPr lang="en-US" sz="1600" dirty="0">
+                <a:solidFill>
+                  <a:srgbClr val="3D3A36"/>
+                </a:solidFill>
+                <a:latin typeface="Calibri" pitchFamily="34" charset="0"/>
+                <a:ea typeface="Calibri" pitchFamily="34" charset="-122"/>
+                <a:cs typeface="Calibri" pitchFamily="34" charset="-120"/>
+              </a:rPr>
+              <a:t>Example: you acclimatise to Nanjing's summer heat after a few weeks.</a:t>
+            </a:r>
+            <a:endParaRPr lang="en-US" sz="1600" dirty="0"/>
+          </a:p>
+          <a:p>
+            <a:pPr marL="342900" indent="-342900">
+              <a:spcAft>
+                <a:spcPts val="800"/>
+              </a:spcAft>
+              <a:buSzPct val="100000"/>
+              <a:buChar char="•"/>
+            </a:pPr>
+            <a:r>
+              <a:rPr lang="en-US" sz="1600" dirty="0">
+                <a:solidFill>
+                  <a:srgbClr val="3D3A36"/>
+                </a:solidFill>
+                <a:latin typeface="Calibri" pitchFamily="34" charset="0"/>
+                <a:ea typeface="Calibri" pitchFamily="34" charset="-122"/>
+                <a:cs typeface="Calibri" pitchFamily="34" charset="-120"/>
+              </a:rPr>
+              <a:t>But you didn't EVOLVE to handle it — your body just adjusted temporarily.</a:t>
+            </a:r>
+            <a:endParaRPr lang="en-US" sz="1600" dirty="0"/>
+          </a:p>
+          <a:p>
+            <a:pPr marL="342900" indent="-342900">
+              <a:spcAft>
+                <a:spcPts val="800"/>
+              </a:spcAft>
+              <a:buSzPct val="100000"/>
+              <a:buChar char="•"/>
+            </a:pPr>
+            <a:r>
+              <a:rPr lang="en-US" sz="1600" dirty="0">
+                <a:solidFill>
+                  <a:srgbClr val="3D3A36"/>
+                </a:solidFill>
+                <a:latin typeface="Calibri" pitchFamily="34" charset="0"/>
+                <a:ea typeface="Calibri" pitchFamily="34" charset="-122"/>
+                <a:cs typeface="Calibri" pitchFamily="34" charset="-120"/>
+              </a:rPr>
+              <a:t>A polar bear can't acclimatise to a tropical forest.</a:t>
+            </a:r>
+            <a:endParaRPr lang="en-US" sz="1600" dirty="0"/>
+          </a:p>
+        </p:txBody>
+      </p:sp>
+    </p:spTree>
+  </p:cSld>
+  <p:clrMapOvr>
+    <a:masterClrMapping/>
+  </p:clrMapOvr>
+</p:sld>
+</file>
+
+<file path=ppt/slides/slide7.xml><?xml version="1.0" encoding="utf-8"?>
+<p:sld xmlns:a="http://schemas.openxmlformats.org/drawingml/2006/main" xmlns:r="http://schemas.openxmlformats.org/officeDocument/2006/relationships" xmlns:p="http://schemas.openxmlformats.org/presentationml/2006/main">
+  <p:cSld name="Slide 7">
+    <p:bg>
+      <p:bgPr>
+        <a:solidFill>
+          <a:srgbClr val="FAF8F5"/>
+        </a:solidFill>
+      </p:bgPr>
+    </p:bg>
+    <p:spTree>
+      <p:nvGrpSpPr>
+        <p:cNvPr id="1" name=""/>
+        <p:cNvGrpSpPr/>
+        <p:nvPr/>
+      </p:nvGrpSpPr>
+      <p:grpSpPr>
+        <a:xfrm>
+          <a:off x="0" y="0"/>
+          <a:ext cx="0" cy="0"/>
+          <a:chOff x="0" y="0"/>
+          <a:chExt cx="0" cy="0"/>
+        </a:xfrm>
+      </p:grpSpPr>
+      <p:sp>
+        <p:nvSpPr>
+          <p:cNvPr id="2" name="Shape 0"/>
+          <p:cNvSpPr/>
+          <p:nvPr/>
+        </p:nvSpPr>
+        <p:spPr>
+          <a:xfrm>
+            <a:off x="0" y="0"/>
+            <a:ext cx="9144000" cy="822960"/>
+          </a:xfrm>
+          <a:prstGeom prst="rect">
+            <a:avLst/>
+          </a:prstGeom>
+          <a:solidFill>
+            <a:srgbClr val="FFFFFF"/>
+          </a:solidFill>
+          <a:ln/>
+        </p:spPr>
+      </p:sp>
+      <p:sp>
+        <p:nvSpPr>
+          <p:cNvPr id="3" name="Shape 1"/>
+          <p:cNvSpPr/>
+          <p:nvPr/>
+        </p:nvSpPr>
+        <p:spPr>
+          <a:xfrm>
+            <a:off x="0" y="795528"/>
+            <a:ext cx="9144000" cy="27432"/>
+          </a:xfrm>
+          <a:prstGeom prst="rect">
+            <a:avLst/>
+          </a:prstGeom>
+          <a:solidFill>
+            <a:srgbClr val="2A9D8F"/>
+          </a:solidFill>
+          <a:ln/>
+        </p:spPr>
+      </p:sp>
+      <p:sp>
+        <p:nvSpPr>
+          <p:cNvPr id="4" name="Text 2"/>
+          <p:cNvSpPr/>
+          <p:nvPr/>
+        </p:nvSpPr>
+        <p:spPr>
+          <a:xfrm>
+            <a:off x="640080" y="91440"/>
+            <a:ext cx="7863840" cy="640080"/>
           </a:xfrm>
           <a:prstGeom prst="rect">
             <a:avLst/>
@@ -2789,16 +3484,690 @@
           <a:ln/>
         </p:spPr>
         <p:txBody>
-          <a:bodyPr wrap="square" rtlCol="0" anchor="ctr"/>
+          <a:bodyPr wrap="square" lIns="0" tIns="0" rIns="0" bIns="0" rtlCol="0" anchor="ctr"/>
           <a:lstStyle/>
           <a:p>
             <a:pPr indent="0" marL="0">
               <a:buNone/>
             </a:pPr>
             <a:r>
+              <a:rPr lang="en-US" sz="2200" b="1" dirty="0">
+                <a:solidFill>
+                  <a:srgbClr val="1B2A4A"/>
+                </a:solidFill>
+                <a:latin typeface="Georgia" pitchFamily="34" charset="0"/>
+                <a:ea typeface="Georgia" pitchFamily="34" charset="-122"/>
+                <a:cs typeface="Georgia" pitchFamily="34" charset="-120"/>
+              </a:rPr>
+              <a:t>Recommended Videos</a:t>
+            </a:r>
+            <a:endParaRPr lang="en-US" sz="2200" dirty="0"/>
+          </a:p>
+        </p:txBody>
+      </p:sp>
+      <p:sp>
+        <p:nvSpPr>
+          <p:cNvPr id="5" name="Text 3"/>
+          <p:cNvSpPr/>
+          <p:nvPr/>
+        </p:nvSpPr>
+        <p:spPr>
+          <a:xfrm>
+            <a:off x="640080" y="868680"/>
+            <a:ext cx="7863840" cy="274320"/>
+          </a:xfrm>
+          <a:prstGeom prst="rect">
+            <a:avLst/>
+          </a:prstGeom>
+          <a:noFill/>
+          <a:ln/>
+        </p:spPr>
+        <p:txBody>
+          <a:bodyPr wrap="square" rtlCol="0" anchor="ctr"/>
+          <a:lstStyle/>
+          <a:p>
+            <a:pPr indent="0" marL="0">
+              <a:buNone/>
+            </a:pPr>
+            <a:r>
+              <a:rPr lang="en-US" sz="1200" i="1" dirty="0">
+                <a:solidFill>
+                  <a:srgbClr val="6B6660"/>
+                </a:solidFill>
+                <a:latin typeface="Calibri" pitchFamily="34" charset="0"/>
+                <a:ea typeface="Calibri" pitchFamily="34" charset="-122"/>
+                <a:cs typeface="Calibri" pitchFamily="34" charset="-120"/>
+              </a:rPr>
+              <a:t>Search these on YouTube to learn more.</a:t>
+            </a:r>
+            <a:endParaRPr lang="en-US" sz="1200" dirty="0"/>
+          </a:p>
+        </p:txBody>
+      </p:sp>
+      <p:sp>
+        <p:nvSpPr>
+          <p:cNvPr id="6" name="Shape 4"/>
+          <p:cNvSpPr/>
+          <p:nvPr/>
+        </p:nvSpPr>
+        <p:spPr>
+          <a:xfrm>
+            <a:off x="457200" y="1234440"/>
+            <a:ext cx="8229600" cy="1051560"/>
+          </a:xfrm>
+          <a:prstGeom prst="rect">
+            <a:avLst/>
+          </a:prstGeom>
+          <a:solidFill>
+            <a:srgbClr val="FFFFFF"/>
+          </a:solidFill>
+          <a:ln/>
+          <a:effectLst>
+            <a:outerShdw sx="100000" sy="100000" kx="0" ky="0" algn="bl" rotWithShape="0" blurRad="76200" dist="25400" dir="8100000">
+              <a:srgbClr val="000000">
+                <a:alpha val="12000"/>
+              </a:srgbClr>
+            </a:outerShdw>
+          </a:effectLst>
+        </p:spPr>
+      </p:sp>
+      <p:sp>
+        <p:nvSpPr>
+          <p:cNvPr id="7" name="Shape 5"/>
+          <p:cNvSpPr/>
+          <p:nvPr/>
+        </p:nvSpPr>
+        <p:spPr>
+          <a:xfrm>
+            <a:off x="457200" y="1234440"/>
+            <a:ext cx="64008" cy="1051560"/>
+          </a:xfrm>
+          <a:prstGeom prst="rect">
+            <a:avLst/>
+          </a:prstGeom>
+          <a:solidFill>
+            <a:srgbClr val="2A9D8F"/>
+          </a:solidFill>
+          <a:ln/>
+        </p:spPr>
+      </p:sp>
+      <p:sp>
+        <p:nvSpPr>
+          <p:cNvPr id="8" name="Text 6"/>
+          <p:cNvSpPr/>
+          <p:nvPr/>
+        </p:nvSpPr>
+        <p:spPr>
+          <a:xfrm>
+            <a:off x="640080" y="1325880"/>
+            <a:ext cx="457200" cy="457200"/>
+          </a:xfrm>
+          <a:prstGeom prst="rect">
+            <a:avLst/>
+          </a:prstGeom>
+          <a:noFill/>
+          <a:ln/>
+        </p:spPr>
+        <p:txBody>
+          <a:bodyPr wrap="square" rtlCol="0" anchor="ctr"/>
+          <a:lstStyle/>
+          <a:p>
+            <a:pPr algn="ctr" indent="0" marL="0">
+              <a:buNone/>
+            </a:pPr>
+            <a:r>
+              <a:rPr lang="en-US" sz="2000" dirty="0">
+                <a:solidFill>
+                  <a:srgbClr val="2A9D8F"/>
+                </a:solidFill>
+                <a:latin typeface="Calibri" pitchFamily="34" charset="0"/>
+                <a:ea typeface="Calibri" pitchFamily="34" charset="-122"/>
+                <a:cs typeface="Calibri" pitchFamily="34" charset="-120"/>
+              </a:rPr>
+              <a:t>▶</a:t>
+            </a:r>
+            <a:endParaRPr lang="en-US" sz="2000" dirty="0"/>
+          </a:p>
+        </p:txBody>
+      </p:sp>
+      <p:sp>
+        <p:nvSpPr>
+          <p:cNvPr id="9" name="Text 7"/>
+          <p:cNvSpPr/>
+          <p:nvPr/>
+        </p:nvSpPr>
+        <p:spPr>
+          <a:xfrm>
+            <a:off x="1188720" y="1307592"/>
+            <a:ext cx="7132320" cy="411480"/>
+          </a:xfrm>
+          <a:prstGeom prst="rect">
+            <a:avLst/>
+          </a:prstGeom>
+          <a:noFill/>
+          <a:ln/>
+        </p:spPr>
+        <p:txBody>
+          <a:bodyPr wrap="square" rtlCol="0" anchor="ctr"/>
+          <a:lstStyle/>
+          <a:p>
+            <a:pPr indent="0" marL="0">
+              <a:buNone/>
+            </a:pPr>
+            <a:r>
+              <a:rPr lang="en-US" sz="1400" b="1" dirty="0">
+                <a:solidFill>
+                  <a:srgbClr val="1B2A4A"/>
+                </a:solidFill>
+                <a:latin typeface="Calibri" pitchFamily="34" charset="0"/>
+                <a:ea typeface="Calibri" pitchFamily="34" charset="-122"/>
+                <a:cs typeface="Calibri" pitchFamily="34" charset="-120"/>
+              </a:rPr>
+              <a:t>What are Adaptations?</a:t>
+            </a:r>
+            <a:endParaRPr lang="en-US" sz="1400" dirty="0"/>
+          </a:p>
+        </p:txBody>
+      </p:sp>
+      <p:sp>
+        <p:nvSpPr>
+          <p:cNvPr id="10" name="Text 8"/>
+          <p:cNvSpPr/>
+          <p:nvPr/>
+        </p:nvSpPr>
+        <p:spPr>
+          <a:xfrm>
+            <a:off x="1188720" y="1691640"/>
+            <a:ext cx="7132320" cy="320040"/>
+          </a:xfrm>
+          <a:prstGeom prst="rect">
+            <a:avLst/>
+          </a:prstGeom>
+          <a:noFill/>
+          <a:ln/>
+        </p:spPr>
+        <p:txBody>
+          <a:bodyPr wrap="square" rtlCol="0" anchor="ctr"/>
+          <a:lstStyle/>
+          <a:p>
+            <a:pPr indent="0" marL="0">
+              <a:buNone/>
+            </a:pPr>
+            <a:r>
               <a:rPr lang="en-US" sz="1100" dirty="0">
                 <a:solidFill>
-                  <a:srgbClr val="E9C46A"/>
+                  <a:srgbClr val="6B6660"/>
+                </a:solidFill>
+                <a:latin typeface="Calibri" pitchFamily="34" charset="0"/>
+                <a:ea typeface="Calibri" pitchFamily="34" charset="-122"/>
+                <a:cs typeface="Calibri" pitchFamily="34" charset="-120"/>
+              </a:rPr>
+              <a:t>FuseSchool  •  4 min</a:t>
+            </a:r>
+            <a:endParaRPr lang="en-US" sz="1100" dirty="0"/>
+          </a:p>
+        </p:txBody>
+      </p:sp>
+      <p:sp>
+        <p:nvSpPr>
+          <p:cNvPr id="11" name="Shape 9"/>
+          <p:cNvSpPr/>
+          <p:nvPr/>
+        </p:nvSpPr>
+        <p:spPr>
+          <a:xfrm>
+            <a:off x="457200" y="2423160"/>
+            <a:ext cx="8229600" cy="1051560"/>
+          </a:xfrm>
+          <a:prstGeom prst="rect">
+            <a:avLst/>
+          </a:prstGeom>
+          <a:solidFill>
+            <a:srgbClr val="FFFFFF"/>
+          </a:solidFill>
+          <a:ln/>
+          <a:effectLst>
+            <a:outerShdw sx="100000" sy="100000" kx="0" ky="0" algn="bl" rotWithShape="0" blurRad="76200" dist="25400" dir="8100000">
+              <a:srgbClr val="000000">
+                <a:alpha val="12000"/>
+              </a:srgbClr>
+            </a:outerShdw>
+          </a:effectLst>
+        </p:spPr>
+      </p:sp>
+      <p:sp>
+        <p:nvSpPr>
+          <p:cNvPr id="12" name="Shape 10"/>
+          <p:cNvSpPr/>
+          <p:nvPr/>
+        </p:nvSpPr>
+        <p:spPr>
+          <a:xfrm>
+            <a:off x="457200" y="2423160"/>
+            <a:ext cx="64008" cy="1051560"/>
+          </a:xfrm>
+          <a:prstGeom prst="rect">
+            <a:avLst/>
+          </a:prstGeom>
+          <a:solidFill>
+            <a:srgbClr val="2A9D8F"/>
+          </a:solidFill>
+          <a:ln/>
+        </p:spPr>
+      </p:sp>
+      <p:sp>
+        <p:nvSpPr>
+          <p:cNvPr id="13" name="Text 11"/>
+          <p:cNvSpPr/>
+          <p:nvPr/>
+        </p:nvSpPr>
+        <p:spPr>
+          <a:xfrm>
+            <a:off x="640080" y="2514600"/>
+            <a:ext cx="457200" cy="457200"/>
+          </a:xfrm>
+          <a:prstGeom prst="rect">
+            <a:avLst/>
+          </a:prstGeom>
+          <a:noFill/>
+          <a:ln/>
+        </p:spPr>
+        <p:txBody>
+          <a:bodyPr wrap="square" rtlCol="0" anchor="ctr"/>
+          <a:lstStyle/>
+          <a:p>
+            <a:pPr algn="ctr" indent="0" marL="0">
+              <a:buNone/>
+            </a:pPr>
+            <a:r>
+              <a:rPr lang="en-US" sz="2000" dirty="0">
+                <a:solidFill>
+                  <a:srgbClr val="2A9D8F"/>
+                </a:solidFill>
+                <a:latin typeface="Calibri" pitchFamily="34" charset="0"/>
+                <a:ea typeface="Calibri" pitchFamily="34" charset="-122"/>
+                <a:cs typeface="Calibri" pitchFamily="34" charset="-120"/>
+              </a:rPr>
+              <a:t>▶</a:t>
+            </a:r>
+            <a:endParaRPr lang="en-US" sz="2000" dirty="0"/>
+          </a:p>
+        </p:txBody>
+      </p:sp>
+      <p:sp>
+        <p:nvSpPr>
+          <p:cNvPr id="14" name="Text 12"/>
+          <p:cNvSpPr/>
+          <p:nvPr/>
+        </p:nvSpPr>
+        <p:spPr>
+          <a:xfrm>
+            <a:off x="1188720" y="2496312"/>
+            <a:ext cx="7132320" cy="411480"/>
+          </a:xfrm>
+          <a:prstGeom prst="rect">
+            <a:avLst/>
+          </a:prstGeom>
+          <a:noFill/>
+          <a:ln/>
+        </p:spPr>
+        <p:txBody>
+          <a:bodyPr wrap="square" rtlCol="0" anchor="ctr"/>
+          <a:lstStyle/>
+          <a:p>
+            <a:pPr indent="0" marL="0">
+              <a:buNone/>
+            </a:pPr>
+            <a:r>
+              <a:rPr lang="en-US" sz="1400" b="1" dirty="0">
+                <a:solidFill>
+                  <a:srgbClr val="1B2A4A"/>
+                </a:solidFill>
+                <a:latin typeface="Calibri" pitchFamily="34" charset="0"/>
+                <a:ea typeface="Calibri" pitchFamily="34" charset="-122"/>
+                <a:cs typeface="Calibri" pitchFamily="34" charset="-120"/>
+              </a:rPr>
+              <a:t>Animal Adaptations</a:t>
+            </a:r>
+            <a:endParaRPr lang="en-US" sz="1400" dirty="0"/>
+          </a:p>
+        </p:txBody>
+      </p:sp>
+      <p:sp>
+        <p:nvSpPr>
+          <p:cNvPr id="15" name="Text 13"/>
+          <p:cNvSpPr/>
+          <p:nvPr/>
+        </p:nvSpPr>
+        <p:spPr>
+          <a:xfrm>
+            <a:off x="1188720" y="2880360"/>
+            <a:ext cx="7132320" cy="320040"/>
+          </a:xfrm>
+          <a:prstGeom prst="rect">
+            <a:avLst/>
+          </a:prstGeom>
+          <a:noFill/>
+          <a:ln/>
+        </p:spPr>
+        <p:txBody>
+          <a:bodyPr wrap="square" rtlCol="0" anchor="ctr"/>
+          <a:lstStyle/>
+          <a:p>
+            <a:pPr indent="0" marL="0">
+              <a:buNone/>
+            </a:pPr>
+            <a:r>
+              <a:rPr lang="en-US" sz="1100" dirty="0">
+                <a:solidFill>
+                  <a:srgbClr val="6B6660"/>
+                </a:solidFill>
+                <a:latin typeface="Calibri" pitchFamily="34" charset="0"/>
+                <a:ea typeface="Calibri" pitchFamily="34" charset="-122"/>
+                <a:cs typeface="Calibri" pitchFamily="34" charset="-120"/>
+              </a:rPr>
+              <a:t>It's AumSum Time  •  6 min</a:t>
+            </a:r>
+            <a:endParaRPr lang="en-US" sz="1100" dirty="0"/>
+          </a:p>
+        </p:txBody>
+      </p:sp>
+      <p:sp>
+        <p:nvSpPr>
+          <p:cNvPr id="16" name="Shape 14"/>
+          <p:cNvSpPr/>
+          <p:nvPr/>
+        </p:nvSpPr>
+        <p:spPr>
+          <a:xfrm>
+            <a:off x="457200" y="3611880"/>
+            <a:ext cx="8229600" cy="1051560"/>
+          </a:xfrm>
+          <a:prstGeom prst="rect">
+            <a:avLst/>
+          </a:prstGeom>
+          <a:solidFill>
+            <a:srgbClr val="FFFFFF"/>
+          </a:solidFill>
+          <a:ln/>
+          <a:effectLst>
+            <a:outerShdw sx="100000" sy="100000" kx="0" ky="0" algn="bl" rotWithShape="0" blurRad="76200" dist="25400" dir="8100000">
+              <a:srgbClr val="000000">
+                <a:alpha val="12000"/>
+              </a:srgbClr>
+            </a:outerShdw>
+          </a:effectLst>
+        </p:spPr>
+      </p:sp>
+      <p:sp>
+        <p:nvSpPr>
+          <p:cNvPr id="17" name="Shape 15"/>
+          <p:cNvSpPr/>
+          <p:nvPr/>
+        </p:nvSpPr>
+        <p:spPr>
+          <a:xfrm>
+            <a:off x="457200" y="3611880"/>
+            <a:ext cx="64008" cy="1051560"/>
+          </a:xfrm>
+          <a:prstGeom prst="rect">
+            <a:avLst/>
+          </a:prstGeom>
+          <a:solidFill>
+            <a:srgbClr val="2A9D8F"/>
+          </a:solidFill>
+          <a:ln/>
+        </p:spPr>
+      </p:sp>
+      <p:sp>
+        <p:nvSpPr>
+          <p:cNvPr id="18" name="Text 16"/>
+          <p:cNvSpPr/>
+          <p:nvPr/>
+        </p:nvSpPr>
+        <p:spPr>
+          <a:xfrm>
+            <a:off x="640080" y="3703320"/>
+            <a:ext cx="457200" cy="457200"/>
+          </a:xfrm>
+          <a:prstGeom prst="rect">
+            <a:avLst/>
+          </a:prstGeom>
+          <a:noFill/>
+          <a:ln/>
+        </p:spPr>
+        <p:txBody>
+          <a:bodyPr wrap="square" rtlCol="0" anchor="ctr"/>
+          <a:lstStyle/>
+          <a:p>
+            <a:pPr algn="ctr" indent="0" marL="0">
+              <a:buNone/>
+            </a:pPr>
+            <a:r>
+              <a:rPr lang="en-US" sz="2000" dirty="0">
+                <a:solidFill>
+                  <a:srgbClr val="2A9D8F"/>
+                </a:solidFill>
+                <a:latin typeface="Calibri" pitchFamily="34" charset="0"/>
+                <a:ea typeface="Calibri" pitchFamily="34" charset="-122"/>
+                <a:cs typeface="Calibri" pitchFamily="34" charset="-120"/>
+              </a:rPr>
+              <a:t>▶</a:t>
+            </a:r>
+            <a:endParaRPr lang="en-US" sz="2000" dirty="0"/>
+          </a:p>
+        </p:txBody>
+      </p:sp>
+      <p:sp>
+        <p:nvSpPr>
+          <p:cNvPr id="19" name="Text 17"/>
+          <p:cNvSpPr/>
+          <p:nvPr/>
+        </p:nvSpPr>
+        <p:spPr>
+          <a:xfrm>
+            <a:off x="1188720" y="3685032"/>
+            <a:ext cx="7132320" cy="411480"/>
+          </a:xfrm>
+          <a:prstGeom prst="rect">
+            <a:avLst/>
+          </a:prstGeom>
+          <a:noFill/>
+          <a:ln/>
+        </p:spPr>
+        <p:txBody>
+          <a:bodyPr wrap="square" rtlCol="0" anchor="ctr"/>
+          <a:lstStyle/>
+          <a:p>
+            <a:pPr indent="0" marL="0">
+              <a:buNone/>
+            </a:pPr>
+            <a:r>
+              <a:rPr lang="en-US" sz="1400" b="1" dirty="0">
+                <a:solidFill>
+                  <a:srgbClr val="1B2A4A"/>
+                </a:solidFill>
+                <a:latin typeface="Calibri" pitchFamily="34" charset="0"/>
+                <a:ea typeface="Calibri" pitchFamily="34" charset="-122"/>
+                <a:cs typeface="Calibri" pitchFamily="34" charset="-120"/>
+              </a:rPr>
+              <a:t>How Do Organisms Adapt?</a:t>
+            </a:r>
+            <a:endParaRPr lang="en-US" sz="1400" dirty="0"/>
+          </a:p>
+        </p:txBody>
+      </p:sp>
+      <p:sp>
+        <p:nvSpPr>
+          <p:cNvPr id="20" name="Text 18"/>
+          <p:cNvSpPr/>
+          <p:nvPr/>
+        </p:nvSpPr>
+        <p:spPr>
+          <a:xfrm>
+            <a:off x="1188720" y="4069080"/>
+            <a:ext cx="7132320" cy="320040"/>
+          </a:xfrm>
+          <a:prstGeom prst="rect">
+            <a:avLst/>
+          </a:prstGeom>
+          <a:noFill/>
+          <a:ln/>
+        </p:spPr>
+        <p:txBody>
+          <a:bodyPr wrap="square" rtlCol="0" anchor="ctr"/>
+          <a:lstStyle/>
+          <a:p>
+            <a:pPr indent="0" marL="0">
+              <a:buNone/>
+            </a:pPr>
+            <a:r>
+              <a:rPr lang="en-US" sz="1100" dirty="0">
+                <a:solidFill>
+                  <a:srgbClr val="6B6660"/>
+                </a:solidFill>
+                <a:latin typeface="Calibri" pitchFamily="34" charset="0"/>
+                <a:ea typeface="Calibri" pitchFamily="34" charset="-122"/>
+                <a:cs typeface="Calibri" pitchFamily="34" charset="-120"/>
+              </a:rPr>
+              <a:t>Cognito  •  5 min</a:t>
+            </a:r>
+            <a:endParaRPr lang="en-US" sz="1100" dirty="0"/>
+          </a:p>
+        </p:txBody>
+      </p:sp>
+    </p:spTree>
+  </p:cSld>
+  <p:clrMapOvr>
+    <a:masterClrMapping/>
+  </p:clrMapOvr>
+</p:sld>
+</file>
+
+<file path=ppt/slides/slide8.xml><?xml version="1.0" encoding="utf-8"?>
+<p:sld xmlns:a="http://schemas.openxmlformats.org/drawingml/2006/main" xmlns:r="http://schemas.openxmlformats.org/officeDocument/2006/relationships" xmlns:p="http://schemas.openxmlformats.org/presentationml/2006/main">
+  <p:cSld name="Slide 8">
+    <p:spTree>
+      <p:nvGrpSpPr>
+        <p:cNvPr id="1" name=""/>
+        <p:cNvGrpSpPr/>
+        <p:nvPr/>
+      </p:nvGrpSpPr>
+      <p:grpSpPr>
+        <a:xfrm>
+          <a:off x="0" y="0"/>
+          <a:ext cx="0" cy="0"/>
+          <a:chOff x="0" y="0"/>
+          <a:chExt cx="0" cy="0"/>
+        </a:xfrm>
+      </p:grpSpPr>
+      <p:sp>
+        <p:nvSpPr>
+          <p:cNvPr id="2" name="Shape 0"/>
+          <p:cNvSpPr/>
+          <p:nvPr/>
+        </p:nvSpPr>
+        <p:spPr>
+          <a:xfrm>
+            <a:off x="0" y="0"/>
+            <a:ext cx="9144000" cy="5143500"/>
+          </a:xfrm>
+          <a:prstGeom prst="rect">
+            <a:avLst/>
+          </a:prstGeom>
+          <a:solidFill>
+            <a:srgbClr val="1B2A4A"/>
+          </a:solidFill>
+          <a:ln/>
+        </p:spPr>
+      </p:sp>
+      <p:sp>
+        <p:nvSpPr>
+          <p:cNvPr id="3" name="Shape 1"/>
+          <p:cNvSpPr/>
+          <p:nvPr/>
+        </p:nvSpPr>
+        <p:spPr>
+          <a:xfrm>
+            <a:off x="0" y="4777740"/>
+            <a:ext cx="9144000" cy="365760"/>
+          </a:xfrm>
+          <a:prstGeom prst="rect">
+            <a:avLst/>
+          </a:prstGeom>
+          <a:solidFill>
+            <a:srgbClr val="2A9D8F"/>
+          </a:solidFill>
+          <a:ln/>
+        </p:spPr>
+      </p:sp>
+      <p:sp>
+        <p:nvSpPr>
+          <p:cNvPr id="4" name="Text 2"/>
+          <p:cNvSpPr/>
+          <p:nvPr/>
+        </p:nvSpPr>
+        <p:spPr>
+          <a:xfrm>
+            <a:off x="731520" y="1371600"/>
+            <a:ext cx="7680960" cy="914400"/>
+          </a:xfrm>
+          <a:prstGeom prst="rect">
+            <a:avLst/>
+          </a:prstGeom>
+          <a:noFill/>
+          <a:ln/>
+        </p:spPr>
+        <p:txBody>
+          <a:bodyPr wrap="square" rtlCol="0" anchor="ctr"/>
+          <a:lstStyle/>
+          <a:p>
+            <a:pPr algn="ctr" indent="0" marL="0">
+              <a:buNone/>
+            </a:pPr>
+            <a:r>
+              <a:rPr lang="en-US" sz="3600" b="1" dirty="0">
+                <a:solidFill>
+                  <a:srgbClr val="FFFFFF"/>
+                </a:solidFill>
+                <a:latin typeface="Georgia" pitchFamily="34" charset="0"/>
+                <a:ea typeface="Georgia" pitchFamily="34" charset="-122"/>
+                <a:cs typeface="Georgia" pitchFamily="34" charset="-120"/>
+              </a:rPr>
+              <a:t>Review &amp; Practise</a:t>
+            </a:r>
+            <a:endParaRPr lang="en-US" sz="3600" dirty="0"/>
+          </a:p>
+        </p:txBody>
+      </p:sp>
+      <p:sp>
+        <p:nvSpPr>
+          <p:cNvPr id="5" name="Text 3"/>
+          <p:cNvSpPr/>
+          <p:nvPr/>
+        </p:nvSpPr>
+        <p:spPr>
+          <a:xfrm>
+            <a:off x="731520" y="2560320"/>
+            <a:ext cx="7680960" cy="548640"/>
+          </a:xfrm>
+          <a:prstGeom prst="rect">
+            <a:avLst/>
+          </a:prstGeom>
+          <a:noFill/>
+          <a:ln/>
+        </p:spPr>
+        <p:txBody>
+          <a:bodyPr wrap="square" rtlCol="0" anchor="ctr"/>
+          <a:lstStyle/>
+          <a:p>
+            <a:pPr algn="ctr" indent="0" marL="0">
+              <a:buNone/>
+            </a:pPr>
+            <a:r>
+              <a:rPr lang="en-US" sz="2000" dirty="0">
+                <a:solidFill>
+                  <a:srgbClr val="2A9D8F"/>
                 </a:solidFill>
                 <a:latin typeface="Calibri" pitchFamily="34" charset="0"/>
                 <a:ea typeface="Calibri" pitchFamily="34" charset="-122"/>
@@ -2806,7 +4175,7 @@
               </a:rPr>
               <a:t>mrzocchi.com</a:t>
             </a:r>
-            <a:endParaRPr lang="en-US" sz="1100" dirty="0"/>
+            <a:endParaRPr lang="en-US" sz="2000" dirty="0"/>
           </a:p>
         </p:txBody>
       </p:sp>

</xml_diff>